<commit_message>
Remove third presentation slide and update slide numbering
</commit_message>
<xml_diff>
--- a/presentation/EchoGuard.pptx
+++ b/presentation/EchoGuard.pptx
@@ -7,7 +7,6 @@
   <p:sldIdLst>
     <p:sldId id="256" r:id="rId7"/>
     <p:sldId id="257" r:id="rId9"/>
-    <p:sldId id="258" r:id="rId10"/>
     <p:sldId id="259" r:id="rId11"/>
     <p:sldId id="260" r:id="rId12"/>
     <p:sldId id="261" r:id="rId13"/>
@@ -583,89 +582,13 @@
           <a:lstStyle/>
           <a:p>
             <a:r>
-              <a:t>TARGET: 00:25–01:00 | 35 seconds</a:t>
+              <a:t>TARGET: 00:25–01:05 | 40 seconds</a:t>
             </a:r>
           </a:p>
           <a:p/>
           <a:p>
             <a:r>
               <a:t>First, the user chooses what they have: a recording, a suspicious message, or a phone number. EchoGuard runs the relevant check and presents the evidence with a clear explanation. The user then verifies the request through an independent official channel. Today, audio and text are separate inputs: uploading audio does not automatically create a transcript. If a service is unavailable, we show that clearly instead of displaying a successful or safe result.</a:t>
-            </a:r>
-          </a:p>
-        </p:txBody>
-      </p:sp>
-      <p:sp>
-        <p:nvSpPr>
-          <p:cNvPr id="4" name="Slide Number Placeholder 3"/>
-          <p:cNvSpPr>
-            <a:spLocks noGrp="1"/>
-          </p:cNvSpPr>
-          <p:nvPr>
-            <p:ph type="sldNum" idx="5" sz="quarter"/>
-          </p:nvPr>
-        </p:nvSpPr>
-        <p:spPr/>
-      </p:sp>
-    </p:spTree>
-  </p:cSld>
-  <p:clrMapOvr>
-    <a:masterClrMapping/>
-  </p:clrMapOvr>
-</p:notes>
-</file>
-
-<file path=ppt/notesSlides/notesSlide3.xml><?xml version="1.0" encoding="utf-8"?>
-<p:notes xmlns:a="http://schemas.openxmlformats.org/drawingml/2006/main" xmlns:p="http://schemas.openxmlformats.org/presentationml/2006/main" xmlns:r="http://schemas.openxmlformats.org/officeDocument/2006/relationships">
-  <p:cSld>
-    <p:spTree>
-      <p:nvGrpSpPr>
-        <p:cNvPr id="1" name=""/>
-        <p:cNvGrpSpPr/>
-        <p:nvPr/>
-      </p:nvGrpSpPr>
-      <p:grpSpPr>
-        <a:xfrm>
-          <a:off x="0" y="0"/>
-          <a:ext cx="0" cy="0"/>
-          <a:chOff x="0" y="0"/>
-          <a:chExt cx="0" cy="0"/>
-        </a:xfrm>
-      </p:grpSpPr>
-      <p:sp>
-        <p:nvSpPr>
-          <p:cNvPr id="2" name="Slide Image Placeholder 1"/>
-          <p:cNvSpPr>
-            <a:spLocks noGrp="1"/>
-          </p:cNvSpPr>
-          <p:nvPr>
-            <p:ph type="sldImg" idx="2"/>
-          </p:nvPr>
-        </p:nvSpPr>
-        <p:spPr/>
-      </p:sp>
-      <p:sp>
-        <p:nvSpPr>
-          <p:cNvPr id="3" name="Notes Placeholder 2"/>
-          <p:cNvSpPr>
-            <a:spLocks noGrp="1"/>
-          </p:cNvSpPr>
-          <p:nvPr>
-            <p:ph type="body" idx="3" sz="quarter"/>
-          </p:nvPr>
-        </p:nvSpPr>
-        <p:spPr/>
-        <p:txBody>
-          <a:bodyPr/>
-          <a:lstStyle/>
-          <a:p>
-            <a:r>
-              <a:t>TARGET: 01:00–01:35 | 35 seconds</a:t>
-            </a:r>
-          </a:p>
-          <a:p/>
-          <a:p>
-            <a:r>
-              <a:t>EchoGuard has three main capabilities. Voice analysis looks for signs of synthetic speech using DetectifAI when the account is configured. The text scam finder checks the content of messages, including fake internship offers, OTP requests, investment promises and urgent payments. Community reporting adds another source of context from submitted experiences. These results answer different questions, so the current application keeps them separate and avoids numerical scam probabilities.</a:t>
             </a:r>
           </a:p>
         </p:txBody>
@@ -735,7 +658,7 @@
           <a:lstStyle/>
           <a:p>
             <a:r>
-              <a:t>TARGET: 01:35–02:30 | 55 seconds</a:t>
+              <a:t>TARGET: 01:05–02:10 | 65 seconds</a:t>
             </a:r>
           </a:p>
           <a:p/>
@@ -811,7 +734,7 @@
           <a:lstStyle/>
           <a:p>
             <a:r>
-              <a:t>TARGET: 02:30–03:15 | 45 seconds</a:t>
+              <a:t>TARGET: 02:10–03:10 | 60 seconds</a:t>
             </a:r>
           </a:p>
           <a:p/>
@@ -887,7 +810,7 @@
           <a:lstStyle/>
           <a:p>
             <a:r>
-              <a:t>TARGET: 03:15–04:00 | 45 seconds</a:t>
+              <a:t>TARGET: 03:10–04:00 | 50 seconds</a:t>
             </a:r>
           </a:p>
           <a:p/>
@@ -4093,7 +4016,7 @@
               </a:defRPr>
             </a:pPr>
             <a:r>
-              <a:t>01 / 06</a:t>
+              <a:t>01 / 05</a:t>
             </a:r>
           </a:p>
         </p:txBody>
@@ -4669,7 +4592,7 @@
               </a:defRPr>
             </a:pPr>
             <a:r>
-              <a:t>02 / 06</a:t>
+              <a:t>02 / 05</a:t>
             </a:r>
           </a:p>
         </p:txBody>
@@ -5429,853 +5352,6 @@
             </a:pPr>
             <a:r>
               <a:t>Current build: audio and pasted text are separate inputs.</a:t>
-            </a:r>
-          </a:p>
-        </p:txBody>
-      </p:sp>
-    </p:spTree>
-  </p:cSld>
-  <p:clrMapOvr>
-    <a:masterClrMapping/>
-  </p:clrMapOvr>
-  <p:transition spd="med" advClick="1">
-    <p:fade/>
-  </p:transition>
-</p:sld>
-</file>
-
-<file path=ppt/slides/slide3.xml><?xml version="1.0" encoding="utf-8"?>
-<p:sld xmlns:a="http://schemas.openxmlformats.org/drawingml/2006/main" xmlns:p="http://schemas.openxmlformats.org/presentationml/2006/main" xmlns:r="http://schemas.openxmlformats.org/officeDocument/2006/relationships">
-  <p:cSld>
-    <p:bg>
-      <p:bgPr>
-        <a:solidFill>
-          <a:srgbClr val="0A1426"/>
-        </a:solidFill>
-        <a:effectLst/>
-      </p:bgPr>
-    </p:bg>
-    <p:spTree>
-      <p:nvGrpSpPr>
-        <p:cNvPr id="1" name=""/>
-        <p:cNvGrpSpPr/>
-        <p:nvPr/>
-      </p:nvGrpSpPr>
-      <p:grpSpPr/>
-      <p:sp>
-        <p:nvSpPr>
-          <p:cNvPr id="2" name="TextBox 1"/>
-          <p:cNvSpPr txBox="1"/>
-          <p:nvPr/>
-        </p:nvSpPr>
-        <p:spPr>
-          <a:xfrm>
-            <a:off x="594360" y="402336"/>
-            <a:ext cx="10972800" cy="274320"/>
-          </a:xfrm>
-          <a:prstGeom prst="rect">
-            <a:avLst/>
-          </a:prstGeom>
-          <a:noFill/>
-        </p:spPr>
-        <p:txBody>
-          <a:bodyPr wrap="square" lIns="0" rIns="0" tIns="0" bIns="0">
-            <a:spAutoFit/>
-          </a:bodyPr>
-          <a:lstStyle/>
-          <a:p>
-            <a:pPr algn="l">
-              <a:spcAft>
-                <a:spcPts val="800"/>
-              </a:spcAft>
-              <a:defRPr sz="1100" b="1">
-                <a:solidFill>
-                  <a:srgbClr val="69E8DA"/>
-                </a:solidFill>
-                <a:latin typeface="Arial"/>
-              </a:defRPr>
-            </a:pPr>
-            <a:r>
-              <a:t>THREE USEFUL CAPABILITIES</a:t>
-            </a:r>
-          </a:p>
-        </p:txBody>
-      </p:sp>
-      <p:sp>
-        <p:nvSpPr>
-          <p:cNvPr id="3" name="TextBox 2"/>
-          <p:cNvSpPr txBox="1"/>
-          <p:nvPr/>
-        </p:nvSpPr>
-        <p:spPr>
-          <a:xfrm>
-            <a:off x="594360" y="932688"/>
-            <a:ext cx="10972800" cy="914400"/>
-          </a:xfrm>
-          <a:prstGeom prst="rect">
-            <a:avLst/>
-          </a:prstGeom>
-          <a:noFill/>
-        </p:spPr>
-        <p:txBody>
-          <a:bodyPr wrap="square" lIns="0" rIns="0" tIns="0" bIns="0">
-            <a:spAutoFit/>
-          </a:bodyPr>
-          <a:lstStyle/>
-          <a:p>
-            <a:pPr algn="l">
-              <a:spcAft>
-                <a:spcPts val="800"/>
-              </a:spcAft>
-              <a:defRPr sz="3600" b="1">
-                <a:solidFill>
-                  <a:srgbClr val="F3F7FF"/>
-                </a:solidFill>
-                <a:latin typeface="Arial"/>
-              </a:defRPr>
-            </a:pPr>
-            <a:r>
-              <a:t>What it does</a:t>
-            </a:r>
-          </a:p>
-        </p:txBody>
-      </p:sp>
-      <p:cxnSp>
-        <p:nvCxnSpPr>
-          <p:cNvPr id="4" name="Connector 3"/>
-          <p:cNvCxnSpPr/>
-          <p:nvPr/>
-        </p:nvCxnSpPr>
-        <p:spPr>
-          <a:xfrm>
-            <a:off x="594360" y="6419088"/>
-            <a:ext cx="10972800" cy="0"/>
-          </a:xfrm>
-          <a:prstGeom prst="line">
-            <a:avLst/>
-          </a:prstGeom>
-          <a:ln w="15240">
-            <a:solidFill>
-              <a:srgbClr val="2A405A"/>
-            </a:solidFill>
-          </a:ln>
-        </p:spPr>
-        <p:style>
-          <a:lnRef idx="2">
-            <a:schemeClr val="accent1"/>
-          </a:lnRef>
-          <a:fillRef idx="0">
-            <a:schemeClr val="accent1"/>
-          </a:fillRef>
-          <a:effectRef idx="1">
-            <a:schemeClr val="accent1"/>
-          </a:effectRef>
-          <a:fontRef idx="minor">
-            <a:schemeClr val="tx1"/>
-          </a:fontRef>
-        </p:style>
-      </p:cxnSp>
-      <p:sp>
-        <p:nvSpPr>
-          <p:cNvPr id="5" name="TextBox 4"/>
-          <p:cNvSpPr txBox="1"/>
-          <p:nvPr/>
-        </p:nvSpPr>
-        <p:spPr>
-          <a:xfrm>
-            <a:off x="621792" y="6556248"/>
-            <a:ext cx="8229600" cy="182880"/>
-          </a:xfrm>
-          <a:prstGeom prst="rect">
-            <a:avLst/>
-          </a:prstGeom>
-          <a:noFill/>
-        </p:spPr>
-        <p:txBody>
-          <a:bodyPr wrap="square" lIns="0" rIns="0" tIns="0" bIns="0">
-            <a:spAutoFit/>
-          </a:bodyPr>
-          <a:lstStyle/>
-          <a:p>
-            <a:pPr algn="l">
-              <a:spcAft>
-                <a:spcPts val="800"/>
-              </a:spcAft>
-              <a:defRPr sz="1000" b="1">
-                <a:solidFill>
-                  <a:srgbClr val="ADBED5"/>
-                </a:solidFill>
-                <a:latin typeface="Arial"/>
-              </a:defRPr>
-            </a:pPr>
-            <a:r>
-              <a:t>ECHOGUARD  /  UNCLONE AI</a:t>
-            </a:r>
-          </a:p>
-        </p:txBody>
-      </p:sp>
-      <p:sp>
-        <p:nvSpPr>
-          <p:cNvPr id="6" name="TextBox 5"/>
-          <p:cNvSpPr txBox="1"/>
-          <p:nvPr/>
-        </p:nvSpPr>
-        <p:spPr>
-          <a:xfrm>
-            <a:off x="10607040" y="6528816"/>
-            <a:ext cx="960120" cy="228600"/>
-          </a:xfrm>
-          <a:prstGeom prst="rect">
-            <a:avLst/>
-          </a:prstGeom>
-          <a:noFill/>
-        </p:spPr>
-        <p:txBody>
-          <a:bodyPr wrap="square" lIns="0" rIns="0" tIns="0" bIns="0">
-            <a:spAutoFit/>
-          </a:bodyPr>
-          <a:lstStyle/>
-          <a:p>
-            <a:pPr algn="r">
-              <a:spcAft>
-                <a:spcPts val="800"/>
-              </a:spcAft>
-              <a:defRPr sz="1100" b="1">
-                <a:solidFill>
-                  <a:srgbClr val="69E8DA"/>
-                </a:solidFill>
-                <a:latin typeface="Arial"/>
-              </a:defRPr>
-            </a:pPr>
-            <a:r>
-              <a:t>03 / 06</a:t>
-            </a:r>
-          </a:p>
-        </p:txBody>
-      </p:sp>
-      <p:sp>
-        <p:nvSpPr>
-          <p:cNvPr id="7" name="Rounded Rectangle 6"/>
-          <p:cNvSpPr/>
-          <p:nvPr/>
-        </p:nvSpPr>
-        <p:spPr>
-          <a:xfrm>
-            <a:off x="612648" y="2331720"/>
-            <a:ext cx="3474720" cy="2898648"/>
-          </a:xfrm>
-          <a:prstGeom prst="roundRect">
-            <a:avLst>
-              <a:gd name="adj" fmla="val 12000"/>
-            </a:avLst>
-          </a:prstGeom>
-          <a:solidFill>
-            <a:srgbClr val="13243B"/>
-          </a:solidFill>
-          <a:ln>
-            <a:solidFill>
-              <a:srgbClr val="2A405A"/>
-            </a:solidFill>
-          </a:ln>
-        </p:spPr>
-        <p:style>
-          <a:lnRef idx="1">
-            <a:schemeClr val="accent1"/>
-          </a:lnRef>
-          <a:fillRef idx="3">
-            <a:schemeClr val="accent1"/>
-          </a:fillRef>
-          <a:effectRef idx="2">
-            <a:schemeClr val="accent1"/>
-          </a:effectRef>
-          <a:fontRef idx="minor">
-            <a:schemeClr val="lt1"/>
-          </a:fontRef>
-        </p:style>
-        <p:txBody>
-          <a:bodyPr rtlCol="0" anchor="ctr"/>
-          <a:lstStyle/>
-          <a:p>
-            <a:pPr algn="ctr"/>
-          </a:p>
-        </p:txBody>
-      </p:sp>
-      <p:sp>
-        <p:nvSpPr>
-          <p:cNvPr id="8" name="TextBox 7"/>
-          <p:cNvSpPr txBox="1"/>
-          <p:nvPr/>
-        </p:nvSpPr>
-        <p:spPr>
-          <a:xfrm>
-            <a:off x="822960" y="2596896"/>
-            <a:ext cx="3017520" cy="274320"/>
-          </a:xfrm>
-          <a:prstGeom prst="rect">
-            <a:avLst/>
-          </a:prstGeom>
-          <a:noFill/>
-        </p:spPr>
-        <p:txBody>
-          <a:bodyPr wrap="square" lIns="0" rIns="0" tIns="0" bIns="0">
-            <a:spAutoFit/>
-          </a:bodyPr>
-          <a:lstStyle/>
-          <a:p>
-            <a:pPr algn="l">
-              <a:spcAft>
-                <a:spcPts val="800"/>
-              </a:spcAft>
-              <a:defRPr sz="1200" b="1">
-                <a:solidFill>
-                  <a:srgbClr val="69E8DA"/>
-                </a:solidFill>
-                <a:latin typeface="Arial"/>
-              </a:defRPr>
-            </a:pPr>
-            <a:r>
-              <a:t>VOICE</a:t>
-            </a:r>
-          </a:p>
-        </p:txBody>
-      </p:sp>
-      <p:sp>
-        <p:nvSpPr>
-          <p:cNvPr id="9" name="TextBox 8"/>
-          <p:cNvSpPr txBox="1"/>
-          <p:nvPr/>
-        </p:nvSpPr>
-        <p:spPr>
-          <a:xfrm>
-            <a:off x="822960" y="3099816"/>
-            <a:ext cx="3054096" cy="868680"/>
-          </a:xfrm>
-          <a:prstGeom prst="rect">
-            <a:avLst/>
-          </a:prstGeom>
-          <a:noFill/>
-        </p:spPr>
-        <p:txBody>
-          <a:bodyPr wrap="square" lIns="0" rIns="0" tIns="0" bIns="0">
-            <a:spAutoFit/>
-          </a:bodyPr>
-          <a:lstStyle/>
-          <a:p>
-            <a:pPr algn="l">
-              <a:spcAft>
-                <a:spcPts val="800"/>
-              </a:spcAft>
-              <a:defRPr sz="2500" b="1">
-                <a:solidFill>
-                  <a:srgbClr val="F3F7FF"/>
-                </a:solidFill>
-                <a:latin typeface="Arial"/>
-              </a:defRPr>
-            </a:pPr>
-            <a:r>
-              <a:t>Question the recording.</a:t>
-            </a:r>
-          </a:p>
-        </p:txBody>
-      </p:sp>
-      <p:sp>
-        <p:nvSpPr>
-          <p:cNvPr id="10" name="TextBox 9"/>
-          <p:cNvSpPr txBox="1"/>
-          <p:nvPr/>
-        </p:nvSpPr>
-        <p:spPr>
-          <a:xfrm>
-            <a:off x="822960" y="4160520"/>
-            <a:ext cx="3054096" cy="941832"/>
-          </a:xfrm>
-          <a:prstGeom prst="rect">
-            <a:avLst/>
-          </a:prstGeom>
-          <a:noFill/>
-        </p:spPr>
-        <p:txBody>
-          <a:bodyPr wrap="square" lIns="0" rIns="0" tIns="0" bIns="0">
-            <a:spAutoFit/>
-          </a:bodyPr>
-          <a:lstStyle/>
-          <a:p>
-            <a:pPr algn="l">
-              <a:spcAft>
-                <a:spcPts val="800"/>
-              </a:spcAft>
-              <a:defRPr sz="1600" b="0">
-                <a:solidFill>
-                  <a:srgbClr val="ADBED5"/>
-                </a:solidFill>
-                <a:latin typeface="Arial"/>
-              </a:defRPr>
-            </a:pPr>
-            <a:r>
-              <a:t>Checks recordings for signs</a:t>
-            </a:r>
-          </a:p>
-          <a:p>
-            <a:pPr algn="l">
-              <a:spcAft>
-                <a:spcPts val="800"/>
-              </a:spcAft>
-              <a:defRPr sz="1600" b="0">
-                <a:solidFill>
-                  <a:srgbClr val="ADBED5"/>
-                </a:solidFill>
-                <a:latin typeface="Arial"/>
-              </a:defRPr>
-            </a:pPr>
-            <a:r>
-              <a:t>of synthetic speech using</a:t>
-            </a:r>
-          </a:p>
-          <a:p>
-            <a:pPr algn="l">
-              <a:spcAft>
-                <a:spcPts val="800"/>
-              </a:spcAft>
-              <a:defRPr sz="1600" b="0">
-                <a:solidFill>
-                  <a:srgbClr val="ADBED5"/>
-                </a:solidFill>
-                <a:latin typeface="Arial"/>
-              </a:defRPr>
-            </a:pPr>
-            <a:r>
-              <a:t>DetectifAI, when configured.</a:t>
-            </a:r>
-          </a:p>
-        </p:txBody>
-      </p:sp>
-      <p:sp>
-        <p:nvSpPr>
-          <p:cNvPr id="11" name="Rounded Rectangle 10"/>
-          <p:cNvSpPr/>
-          <p:nvPr/>
-        </p:nvSpPr>
-        <p:spPr>
-          <a:xfrm>
-            <a:off x="4361688" y="2331720"/>
-            <a:ext cx="3474720" cy="2898648"/>
-          </a:xfrm>
-          <a:prstGeom prst="roundRect">
-            <a:avLst>
-              <a:gd name="adj" fmla="val 12000"/>
-            </a:avLst>
-          </a:prstGeom>
-          <a:solidFill>
-            <a:srgbClr val="13243B"/>
-          </a:solidFill>
-          <a:ln>
-            <a:solidFill>
-              <a:srgbClr val="2A405A"/>
-            </a:solidFill>
-          </a:ln>
-        </p:spPr>
-        <p:style>
-          <a:lnRef idx="1">
-            <a:schemeClr val="accent1"/>
-          </a:lnRef>
-          <a:fillRef idx="3">
-            <a:schemeClr val="accent1"/>
-          </a:fillRef>
-          <a:effectRef idx="2">
-            <a:schemeClr val="accent1"/>
-          </a:effectRef>
-          <a:fontRef idx="minor">
-            <a:schemeClr val="lt1"/>
-          </a:fontRef>
-        </p:style>
-        <p:txBody>
-          <a:bodyPr rtlCol="0" anchor="ctr"/>
-          <a:lstStyle/>
-          <a:p>
-            <a:pPr algn="ctr"/>
-          </a:p>
-        </p:txBody>
-      </p:sp>
-      <p:sp>
-        <p:nvSpPr>
-          <p:cNvPr id="12" name="TextBox 11"/>
-          <p:cNvSpPr txBox="1"/>
-          <p:nvPr/>
-        </p:nvSpPr>
-        <p:spPr>
-          <a:xfrm>
-            <a:off x="4572000" y="2596896"/>
-            <a:ext cx="3017520" cy="274320"/>
-          </a:xfrm>
-          <a:prstGeom prst="rect">
-            <a:avLst/>
-          </a:prstGeom>
-          <a:noFill/>
-        </p:spPr>
-        <p:txBody>
-          <a:bodyPr wrap="square" lIns="0" rIns="0" tIns="0" bIns="0">
-            <a:spAutoFit/>
-          </a:bodyPr>
-          <a:lstStyle/>
-          <a:p>
-            <a:pPr algn="l">
-              <a:spcAft>
-                <a:spcPts val="800"/>
-              </a:spcAft>
-              <a:defRPr sz="1200" b="1">
-                <a:solidFill>
-                  <a:srgbClr val="BEAEFF"/>
-                </a:solidFill>
-                <a:latin typeface="Arial"/>
-              </a:defRPr>
-            </a:pPr>
-            <a:r>
-              <a:t>TEXT</a:t>
-            </a:r>
-          </a:p>
-        </p:txBody>
-      </p:sp>
-      <p:sp>
-        <p:nvSpPr>
-          <p:cNvPr id="13" name="TextBox 12"/>
-          <p:cNvSpPr txBox="1"/>
-          <p:nvPr/>
-        </p:nvSpPr>
-        <p:spPr>
-          <a:xfrm>
-            <a:off x="4572000" y="3099816"/>
-            <a:ext cx="3054096" cy="868680"/>
-          </a:xfrm>
-          <a:prstGeom prst="rect">
-            <a:avLst/>
-          </a:prstGeom>
-          <a:noFill/>
-        </p:spPr>
-        <p:txBody>
-          <a:bodyPr wrap="square" lIns="0" rIns="0" tIns="0" bIns="0">
-            <a:spAutoFit/>
-          </a:bodyPr>
-          <a:lstStyle/>
-          <a:p>
-            <a:pPr algn="l">
-              <a:spcAft>
-                <a:spcPts val="800"/>
-              </a:spcAft>
-              <a:defRPr sz="2500" b="1">
-                <a:solidFill>
-                  <a:srgbClr val="F3F7FF"/>
-                </a:solidFill>
-                <a:latin typeface="Arial"/>
-              </a:defRPr>
-            </a:pPr>
-            <a:r>
-              <a:t>Understand the request.</a:t>
-            </a:r>
-          </a:p>
-        </p:txBody>
-      </p:sp>
-      <p:sp>
-        <p:nvSpPr>
-          <p:cNvPr id="14" name="TextBox 13"/>
-          <p:cNvSpPr txBox="1"/>
-          <p:nvPr/>
-        </p:nvSpPr>
-        <p:spPr>
-          <a:xfrm>
-            <a:off x="4572000" y="4160520"/>
-            <a:ext cx="3054096" cy="941832"/>
-          </a:xfrm>
-          <a:prstGeom prst="rect">
-            <a:avLst/>
-          </a:prstGeom>
-          <a:noFill/>
-        </p:spPr>
-        <p:txBody>
-          <a:bodyPr wrap="square" lIns="0" rIns="0" tIns="0" bIns="0">
-            <a:spAutoFit/>
-          </a:bodyPr>
-          <a:lstStyle/>
-          <a:p>
-            <a:pPr algn="l">
-              <a:spcAft>
-                <a:spcPts val="800"/>
-              </a:spcAft>
-              <a:defRPr sz="1600" b="0">
-                <a:solidFill>
-                  <a:srgbClr val="ADBED5"/>
-                </a:solidFill>
-                <a:latin typeface="Arial"/>
-              </a:defRPr>
-            </a:pPr>
-            <a:r>
-              <a:t>Checks job offers, banking</a:t>
-            </a:r>
-          </a:p>
-          <a:p>
-            <a:pPr algn="l">
-              <a:spcAft>
-                <a:spcPts val="800"/>
-              </a:spcAft>
-              <a:defRPr sz="1600" b="0">
-                <a:solidFill>
-                  <a:srgbClr val="ADBED5"/>
-                </a:solidFill>
-                <a:latin typeface="Arial"/>
-              </a:defRPr>
-            </a:pPr>
-            <a:r>
-              <a:t>messages, payment demands</a:t>
-            </a:r>
-          </a:p>
-          <a:p>
-            <a:pPr algn="l">
-              <a:spcAft>
-                <a:spcPts val="800"/>
-              </a:spcAft>
-              <a:defRPr sz="1600" b="0">
-                <a:solidFill>
-                  <a:srgbClr val="ADBED5"/>
-                </a:solidFill>
-                <a:latin typeface="Arial"/>
-              </a:defRPr>
-            </a:pPr>
-            <a:r>
-              <a:t>and other suspicious text.</a:t>
-            </a:r>
-          </a:p>
-        </p:txBody>
-      </p:sp>
-      <p:sp>
-        <p:nvSpPr>
-          <p:cNvPr id="15" name="Rounded Rectangle 14"/>
-          <p:cNvSpPr/>
-          <p:nvPr/>
-        </p:nvSpPr>
-        <p:spPr>
-          <a:xfrm>
-            <a:off x="8110727" y="2331720"/>
-            <a:ext cx="3474720" cy="2898648"/>
-          </a:xfrm>
-          <a:prstGeom prst="roundRect">
-            <a:avLst>
-              <a:gd name="adj" fmla="val 12000"/>
-            </a:avLst>
-          </a:prstGeom>
-          <a:solidFill>
-            <a:srgbClr val="13243B"/>
-          </a:solidFill>
-          <a:ln>
-            <a:solidFill>
-              <a:srgbClr val="2A405A"/>
-            </a:solidFill>
-          </a:ln>
-        </p:spPr>
-        <p:style>
-          <a:lnRef idx="1">
-            <a:schemeClr val="accent1"/>
-          </a:lnRef>
-          <a:fillRef idx="3">
-            <a:schemeClr val="accent1"/>
-          </a:fillRef>
-          <a:effectRef idx="2">
-            <a:schemeClr val="accent1"/>
-          </a:effectRef>
-          <a:fontRef idx="minor">
-            <a:schemeClr val="lt1"/>
-          </a:fontRef>
-        </p:style>
-        <p:txBody>
-          <a:bodyPr rtlCol="0" anchor="ctr"/>
-          <a:lstStyle/>
-          <a:p>
-            <a:pPr algn="ctr"/>
-          </a:p>
-        </p:txBody>
-      </p:sp>
-      <p:sp>
-        <p:nvSpPr>
-          <p:cNvPr id="16" name="TextBox 15"/>
-          <p:cNvSpPr txBox="1"/>
-          <p:nvPr/>
-        </p:nvSpPr>
-        <p:spPr>
-          <a:xfrm>
-            <a:off x="8321040" y="2596896"/>
-            <a:ext cx="3017520" cy="274320"/>
-          </a:xfrm>
-          <a:prstGeom prst="rect">
-            <a:avLst/>
-          </a:prstGeom>
-          <a:noFill/>
-        </p:spPr>
-        <p:txBody>
-          <a:bodyPr wrap="square" lIns="0" rIns="0" tIns="0" bIns="0">
-            <a:spAutoFit/>
-          </a:bodyPr>
-          <a:lstStyle/>
-          <a:p>
-            <a:pPr algn="l">
-              <a:spcAft>
-                <a:spcPts val="800"/>
-              </a:spcAft>
-              <a:defRPr sz="1200" b="1">
-                <a:solidFill>
-                  <a:srgbClr val="FFD69D"/>
-                </a:solidFill>
-                <a:latin typeface="Arial"/>
-              </a:defRPr>
-            </a:pPr>
-            <a:r>
-              <a:t>COMMUNITY</a:t>
-            </a:r>
-          </a:p>
-        </p:txBody>
-      </p:sp>
-      <p:sp>
-        <p:nvSpPr>
-          <p:cNvPr id="17" name="TextBox 16"/>
-          <p:cNvSpPr txBox="1"/>
-          <p:nvPr/>
-        </p:nvSpPr>
-        <p:spPr>
-          <a:xfrm>
-            <a:off x="8321040" y="3099816"/>
-            <a:ext cx="3054096" cy="868680"/>
-          </a:xfrm>
-          <a:prstGeom prst="rect">
-            <a:avLst/>
-          </a:prstGeom>
-          <a:noFill/>
-        </p:spPr>
-        <p:txBody>
-          <a:bodyPr wrap="square" lIns="0" rIns="0" tIns="0" bIns="0">
-            <a:spAutoFit/>
-          </a:bodyPr>
-          <a:lstStyle/>
-          <a:p>
-            <a:pPr algn="l">
-              <a:spcAft>
-                <a:spcPts val="800"/>
-              </a:spcAft>
-              <a:defRPr sz="2500" b="1">
-                <a:solidFill>
-                  <a:srgbClr val="F3F7FF"/>
-                </a:solidFill>
-                <a:latin typeface="Arial"/>
-              </a:defRPr>
-            </a:pPr>
-            <a:r>
-              <a:t>Learn from reports.</a:t>
-            </a:r>
-          </a:p>
-        </p:txBody>
-      </p:sp>
-      <p:sp>
-        <p:nvSpPr>
-          <p:cNvPr id="18" name="TextBox 17"/>
-          <p:cNvSpPr txBox="1"/>
-          <p:nvPr/>
-        </p:nvSpPr>
-        <p:spPr>
-          <a:xfrm>
-            <a:off x="8321040" y="4160520"/>
-            <a:ext cx="3054096" cy="941832"/>
-          </a:xfrm>
-          <a:prstGeom prst="rect">
-            <a:avLst/>
-          </a:prstGeom>
-          <a:noFill/>
-        </p:spPr>
-        <p:txBody>
-          <a:bodyPr wrap="square" lIns="0" rIns="0" tIns="0" bIns="0">
-            <a:spAutoFit/>
-          </a:bodyPr>
-          <a:lstStyle/>
-          <a:p>
-            <a:pPr algn="l">
-              <a:spcAft>
-                <a:spcPts val="800"/>
-              </a:spcAft>
-              <a:defRPr sz="1600" b="0">
-                <a:solidFill>
-                  <a:srgbClr val="ADBED5"/>
-                </a:solidFill>
-                <a:latin typeface="Arial"/>
-              </a:defRPr>
-            </a:pPr>
-            <a:r>
-              <a:t>Search phone report totals</a:t>
-            </a:r>
-          </a:p>
-          <a:p>
-            <a:pPr algn="l">
-              <a:spcAft>
-                <a:spcPts val="800"/>
-              </a:spcAft>
-              <a:defRPr sz="1600" b="0">
-                <a:solidFill>
-                  <a:srgbClr val="ADBED5"/>
-                </a:solidFill>
-                <a:latin typeface="Arial"/>
-              </a:defRPr>
-            </a:pPr>
-            <a:r>
-              <a:t>and share suspicious-call</a:t>
-            </a:r>
-          </a:p>
-          <a:p>
-            <a:pPr algn="l">
-              <a:spcAft>
-                <a:spcPts val="800"/>
-              </a:spcAft>
-              <a:defRPr sz="1600" b="0">
-                <a:solidFill>
-                  <a:srgbClr val="ADBED5"/>
-                </a:solidFill>
-                <a:latin typeface="Arial"/>
-              </a:defRPr>
-            </a:pPr>
-            <a:r>
-              <a:t>experiences with others.</a:t>
-            </a:r>
-          </a:p>
-        </p:txBody>
-      </p:sp>
-      <p:sp>
-        <p:nvSpPr>
-          <p:cNvPr id="19" name="TextBox 18"/>
-          <p:cNvSpPr txBox="1"/>
-          <p:nvPr/>
-        </p:nvSpPr>
-        <p:spPr>
-          <a:xfrm>
-            <a:off x="667512" y="5650992"/>
-            <a:ext cx="10881360" cy="438912"/>
-          </a:xfrm>
-          <a:prstGeom prst="rect">
-            <a:avLst/>
-          </a:prstGeom>
-          <a:noFill/>
-        </p:spPr>
-        <p:txBody>
-          <a:bodyPr wrap="square" lIns="0" rIns="0" tIns="0" bIns="0">
-            <a:spAutoFit/>
-          </a:bodyPr>
-          <a:lstStyle/>
-          <a:p>
-            <a:pPr algn="l">
-              <a:spcAft>
-                <a:spcPts val="800"/>
-              </a:spcAft>
-              <a:defRPr sz="2400" b="1">
-                <a:solidFill>
-                  <a:srgbClr val="F3F7FF"/>
-                </a:solidFill>
-                <a:latin typeface="Arial"/>
-              </a:defRPr>
-            </a:pPr>
-            <a:r>
-              <a:t>Clear explanations. No numerical scam probabilities.</a:t>
             </a:r>
           </a:p>
         </p:txBody>
@@ -6495,7 +5571,7 @@
               </a:defRPr>
             </a:pPr>
             <a:r>
-              <a:t>04 / 06</a:t>
+              <a:t>03 / 05</a:t>
             </a:r>
           </a:p>
         </p:txBody>
@@ -7248,7 +6324,7 @@
               </a:defRPr>
             </a:pPr>
             <a:r>
-              <a:t>05 / 06</a:t>
+              <a:t>04 / 05</a:t>
             </a:r>
           </a:p>
         </p:txBody>
@@ -8081,7 +7157,7 @@
               </a:defRPr>
             </a:pPr>
             <a:r>
-              <a:t>06 / 06</a:t>
+              <a:t>05 / 05</a:t>
             </a:r>
           </a:p>
         </p:txBody>

</xml_diff>

<commit_message>
Restore six-slide EchoGuard presentation
</commit_message>
<xml_diff>
--- a/presentation/EchoGuard.pptx
+++ b/presentation/EchoGuard.pptx
@@ -7,6 +7,7 @@
   <p:sldIdLst>
     <p:sldId id="256" r:id="rId7"/>
     <p:sldId id="257" r:id="rId9"/>
+    <p:sldId id="258" r:id="rId10"/>
     <p:sldId id="259" r:id="rId11"/>
     <p:sldId id="260" r:id="rId12"/>
     <p:sldId id="261" r:id="rId13"/>
@@ -582,13 +583,89 @@
           <a:lstStyle/>
           <a:p>
             <a:r>
-              <a:t>TARGET: 00:25–01:05 | 40 seconds</a:t>
+              <a:t>TARGET: 00:25–01:00 | 35 seconds</a:t>
             </a:r>
           </a:p>
           <a:p/>
           <a:p>
             <a:r>
               <a:t>First, the user chooses what they have: a recording, a suspicious message, or a phone number. EchoGuard runs the relevant check and presents the evidence with a clear explanation. The user then verifies the request through an independent official channel. Today, audio and text are separate inputs: uploading audio does not automatically create a transcript. If a service is unavailable, we show that clearly instead of displaying a successful or safe result.</a:t>
+            </a:r>
+          </a:p>
+        </p:txBody>
+      </p:sp>
+      <p:sp>
+        <p:nvSpPr>
+          <p:cNvPr id="4" name="Slide Number Placeholder 3"/>
+          <p:cNvSpPr>
+            <a:spLocks noGrp="1"/>
+          </p:cNvSpPr>
+          <p:nvPr>
+            <p:ph type="sldNum" idx="5" sz="quarter"/>
+          </p:nvPr>
+        </p:nvSpPr>
+        <p:spPr/>
+      </p:sp>
+    </p:spTree>
+  </p:cSld>
+  <p:clrMapOvr>
+    <a:masterClrMapping/>
+  </p:clrMapOvr>
+</p:notes>
+</file>
+
+<file path=ppt/notesSlides/notesSlide3.xml><?xml version="1.0" encoding="utf-8"?>
+<p:notes xmlns:a="http://schemas.openxmlformats.org/drawingml/2006/main" xmlns:p="http://schemas.openxmlformats.org/presentationml/2006/main" xmlns:r="http://schemas.openxmlformats.org/officeDocument/2006/relationships">
+  <p:cSld>
+    <p:spTree>
+      <p:nvGrpSpPr>
+        <p:cNvPr id="1" name=""/>
+        <p:cNvGrpSpPr/>
+        <p:nvPr/>
+      </p:nvGrpSpPr>
+      <p:grpSpPr>
+        <a:xfrm>
+          <a:off x="0" y="0"/>
+          <a:ext cx="0" cy="0"/>
+          <a:chOff x="0" y="0"/>
+          <a:chExt cx="0" cy="0"/>
+        </a:xfrm>
+      </p:grpSpPr>
+      <p:sp>
+        <p:nvSpPr>
+          <p:cNvPr id="2" name="Slide Image Placeholder 1"/>
+          <p:cNvSpPr>
+            <a:spLocks noGrp="1"/>
+          </p:cNvSpPr>
+          <p:nvPr>
+            <p:ph type="sldImg" idx="2"/>
+          </p:nvPr>
+        </p:nvSpPr>
+        <p:spPr/>
+      </p:sp>
+      <p:sp>
+        <p:nvSpPr>
+          <p:cNvPr id="3" name="Notes Placeholder 2"/>
+          <p:cNvSpPr>
+            <a:spLocks noGrp="1"/>
+          </p:cNvSpPr>
+          <p:nvPr>
+            <p:ph type="body" idx="3" sz="quarter"/>
+          </p:nvPr>
+        </p:nvSpPr>
+        <p:spPr/>
+        <p:txBody>
+          <a:bodyPr/>
+          <a:lstStyle/>
+          <a:p>
+            <a:r>
+              <a:t>TARGET: 01:00–01:35 | 35 seconds</a:t>
+            </a:r>
+          </a:p>
+          <a:p/>
+          <a:p>
+            <a:r>
+              <a:t>EchoGuard has three main capabilities. Voice analysis looks for signs of synthetic speech using DetectifAI when the account is configured. The text scam finder checks the content of messages, including fake internship offers, OTP requests, investment promises and urgent payments. Community reporting adds another source of context from submitted experiences. These results answer different questions, so the current application keeps them separate and avoids numerical scam probabilities.</a:t>
             </a:r>
           </a:p>
         </p:txBody>
@@ -658,7 +735,7 @@
           <a:lstStyle/>
           <a:p>
             <a:r>
-              <a:t>TARGET: 01:05–02:10 | 65 seconds</a:t>
+              <a:t>TARGET: 01:35–02:30 | 55 seconds</a:t>
             </a:r>
           </a:p>
           <a:p/>
@@ -734,7 +811,7 @@
           <a:lstStyle/>
           <a:p>
             <a:r>
-              <a:t>TARGET: 02:10–03:10 | 60 seconds</a:t>
+              <a:t>TARGET: 02:30–03:15 | 45 seconds</a:t>
             </a:r>
           </a:p>
           <a:p/>
@@ -810,7 +887,7 @@
           <a:lstStyle/>
           <a:p>
             <a:r>
-              <a:t>TARGET: 03:10–04:00 | 50 seconds</a:t>
+              <a:t>TARGET: 03:15–04:00 | 45 seconds</a:t>
             </a:r>
           </a:p>
           <a:p/>
@@ -4016,7 +4093,7 @@
               </a:defRPr>
             </a:pPr>
             <a:r>
-              <a:t>01 / 05</a:t>
+              <a:t>01 / 06</a:t>
             </a:r>
           </a:p>
         </p:txBody>
@@ -4592,7 +4669,7 @@
               </a:defRPr>
             </a:pPr>
             <a:r>
-              <a:t>02 / 05</a:t>
+              <a:t>02 / 06</a:t>
             </a:r>
           </a:p>
         </p:txBody>
@@ -5352,6 +5429,853 @@
             </a:pPr>
             <a:r>
               <a:t>Current build: audio and pasted text are separate inputs.</a:t>
+            </a:r>
+          </a:p>
+        </p:txBody>
+      </p:sp>
+    </p:spTree>
+  </p:cSld>
+  <p:clrMapOvr>
+    <a:masterClrMapping/>
+  </p:clrMapOvr>
+  <p:transition spd="med" advClick="1">
+    <p:fade/>
+  </p:transition>
+</p:sld>
+</file>
+
+<file path=ppt/slides/slide3.xml><?xml version="1.0" encoding="utf-8"?>
+<p:sld xmlns:a="http://schemas.openxmlformats.org/drawingml/2006/main" xmlns:p="http://schemas.openxmlformats.org/presentationml/2006/main" xmlns:r="http://schemas.openxmlformats.org/officeDocument/2006/relationships">
+  <p:cSld>
+    <p:bg>
+      <p:bgPr>
+        <a:solidFill>
+          <a:srgbClr val="0A1426"/>
+        </a:solidFill>
+        <a:effectLst/>
+      </p:bgPr>
+    </p:bg>
+    <p:spTree>
+      <p:nvGrpSpPr>
+        <p:cNvPr id="1" name=""/>
+        <p:cNvGrpSpPr/>
+        <p:nvPr/>
+      </p:nvGrpSpPr>
+      <p:grpSpPr/>
+      <p:sp>
+        <p:nvSpPr>
+          <p:cNvPr id="2" name="TextBox 1"/>
+          <p:cNvSpPr txBox="1"/>
+          <p:nvPr/>
+        </p:nvSpPr>
+        <p:spPr>
+          <a:xfrm>
+            <a:off x="594360" y="402336"/>
+            <a:ext cx="10972800" cy="274320"/>
+          </a:xfrm>
+          <a:prstGeom prst="rect">
+            <a:avLst/>
+          </a:prstGeom>
+          <a:noFill/>
+        </p:spPr>
+        <p:txBody>
+          <a:bodyPr wrap="square" lIns="0" rIns="0" tIns="0" bIns="0">
+            <a:spAutoFit/>
+          </a:bodyPr>
+          <a:lstStyle/>
+          <a:p>
+            <a:pPr algn="l">
+              <a:spcAft>
+                <a:spcPts val="800"/>
+              </a:spcAft>
+              <a:defRPr sz="1100" b="1">
+                <a:solidFill>
+                  <a:srgbClr val="69E8DA"/>
+                </a:solidFill>
+                <a:latin typeface="Arial"/>
+              </a:defRPr>
+            </a:pPr>
+            <a:r>
+              <a:t>THREE USEFUL CAPABILITIES</a:t>
+            </a:r>
+          </a:p>
+        </p:txBody>
+      </p:sp>
+      <p:sp>
+        <p:nvSpPr>
+          <p:cNvPr id="3" name="TextBox 2"/>
+          <p:cNvSpPr txBox="1"/>
+          <p:nvPr/>
+        </p:nvSpPr>
+        <p:spPr>
+          <a:xfrm>
+            <a:off x="594360" y="932688"/>
+            <a:ext cx="10972800" cy="914400"/>
+          </a:xfrm>
+          <a:prstGeom prst="rect">
+            <a:avLst/>
+          </a:prstGeom>
+          <a:noFill/>
+        </p:spPr>
+        <p:txBody>
+          <a:bodyPr wrap="square" lIns="0" rIns="0" tIns="0" bIns="0">
+            <a:spAutoFit/>
+          </a:bodyPr>
+          <a:lstStyle/>
+          <a:p>
+            <a:pPr algn="l">
+              <a:spcAft>
+                <a:spcPts val="800"/>
+              </a:spcAft>
+              <a:defRPr sz="3600" b="1">
+                <a:solidFill>
+                  <a:srgbClr val="F3F7FF"/>
+                </a:solidFill>
+                <a:latin typeface="Arial"/>
+              </a:defRPr>
+            </a:pPr>
+            <a:r>
+              <a:t>What it does</a:t>
+            </a:r>
+          </a:p>
+        </p:txBody>
+      </p:sp>
+      <p:cxnSp>
+        <p:nvCxnSpPr>
+          <p:cNvPr id="4" name="Connector 3"/>
+          <p:cNvCxnSpPr/>
+          <p:nvPr/>
+        </p:nvCxnSpPr>
+        <p:spPr>
+          <a:xfrm>
+            <a:off x="594360" y="6419088"/>
+            <a:ext cx="10972800" cy="0"/>
+          </a:xfrm>
+          <a:prstGeom prst="line">
+            <a:avLst/>
+          </a:prstGeom>
+          <a:ln w="15240">
+            <a:solidFill>
+              <a:srgbClr val="2A405A"/>
+            </a:solidFill>
+          </a:ln>
+        </p:spPr>
+        <p:style>
+          <a:lnRef idx="2">
+            <a:schemeClr val="accent1"/>
+          </a:lnRef>
+          <a:fillRef idx="0">
+            <a:schemeClr val="accent1"/>
+          </a:fillRef>
+          <a:effectRef idx="1">
+            <a:schemeClr val="accent1"/>
+          </a:effectRef>
+          <a:fontRef idx="minor">
+            <a:schemeClr val="tx1"/>
+          </a:fontRef>
+        </p:style>
+      </p:cxnSp>
+      <p:sp>
+        <p:nvSpPr>
+          <p:cNvPr id="5" name="TextBox 4"/>
+          <p:cNvSpPr txBox="1"/>
+          <p:nvPr/>
+        </p:nvSpPr>
+        <p:spPr>
+          <a:xfrm>
+            <a:off x="621792" y="6556248"/>
+            <a:ext cx="8229600" cy="182880"/>
+          </a:xfrm>
+          <a:prstGeom prst="rect">
+            <a:avLst/>
+          </a:prstGeom>
+          <a:noFill/>
+        </p:spPr>
+        <p:txBody>
+          <a:bodyPr wrap="square" lIns="0" rIns="0" tIns="0" bIns="0">
+            <a:spAutoFit/>
+          </a:bodyPr>
+          <a:lstStyle/>
+          <a:p>
+            <a:pPr algn="l">
+              <a:spcAft>
+                <a:spcPts val="800"/>
+              </a:spcAft>
+              <a:defRPr sz="1000" b="1">
+                <a:solidFill>
+                  <a:srgbClr val="ADBED5"/>
+                </a:solidFill>
+                <a:latin typeface="Arial"/>
+              </a:defRPr>
+            </a:pPr>
+            <a:r>
+              <a:t>ECHOGUARD  /  UNCLONE AI</a:t>
+            </a:r>
+          </a:p>
+        </p:txBody>
+      </p:sp>
+      <p:sp>
+        <p:nvSpPr>
+          <p:cNvPr id="6" name="TextBox 5"/>
+          <p:cNvSpPr txBox="1"/>
+          <p:nvPr/>
+        </p:nvSpPr>
+        <p:spPr>
+          <a:xfrm>
+            <a:off x="10607040" y="6528816"/>
+            <a:ext cx="960120" cy="228600"/>
+          </a:xfrm>
+          <a:prstGeom prst="rect">
+            <a:avLst/>
+          </a:prstGeom>
+          <a:noFill/>
+        </p:spPr>
+        <p:txBody>
+          <a:bodyPr wrap="square" lIns="0" rIns="0" tIns="0" bIns="0">
+            <a:spAutoFit/>
+          </a:bodyPr>
+          <a:lstStyle/>
+          <a:p>
+            <a:pPr algn="r">
+              <a:spcAft>
+                <a:spcPts val="800"/>
+              </a:spcAft>
+              <a:defRPr sz="1100" b="1">
+                <a:solidFill>
+                  <a:srgbClr val="69E8DA"/>
+                </a:solidFill>
+                <a:latin typeface="Arial"/>
+              </a:defRPr>
+            </a:pPr>
+            <a:r>
+              <a:t>03 / 06</a:t>
+            </a:r>
+          </a:p>
+        </p:txBody>
+      </p:sp>
+      <p:sp>
+        <p:nvSpPr>
+          <p:cNvPr id="7" name="Rounded Rectangle 6"/>
+          <p:cNvSpPr/>
+          <p:nvPr/>
+        </p:nvSpPr>
+        <p:spPr>
+          <a:xfrm>
+            <a:off x="612648" y="2331720"/>
+            <a:ext cx="3474720" cy="2898648"/>
+          </a:xfrm>
+          <a:prstGeom prst="roundRect">
+            <a:avLst>
+              <a:gd name="adj" fmla="val 12000"/>
+            </a:avLst>
+          </a:prstGeom>
+          <a:solidFill>
+            <a:srgbClr val="13243B"/>
+          </a:solidFill>
+          <a:ln>
+            <a:solidFill>
+              <a:srgbClr val="2A405A"/>
+            </a:solidFill>
+          </a:ln>
+        </p:spPr>
+        <p:style>
+          <a:lnRef idx="1">
+            <a:schemeClr val="accent1"/>
+          </a:lnRef>
+          <a:fillRef idx="3">
+            <a:schemeClr val="accent1"/>
+          </a:fillRef>
+          <a:effectRef idx="2">
+            <a:schemeClr val="accent1"/>
+          </a:effectRef>
+          <a:fontRef idx="minor">
+            <a:schemeClr val="lt1"/>
+          </a:fontRef>
+        </p:style>
+        <p:txBody>
+          <a:bodyPr rtlCol="0" anchor="ctr"/>
+          <a:lstStyle/>
+          <a:p>
+            <a:pPr algn="ctr"/>
+          </a:p>
+        </p:txBody>
+      </p:sp>
+      <p:sp>
+        <p:nvSpPr>
+          <p:cNvPr id="8" name="TextBox 7"/>
+          <p:cNvSpPr txBox="1"/>
+          <p:nvPr/>
+        </p:nvSpPr>
+        <p:spPr>
+          <a:xfrm>
+            <a:off x="822960" y="2596896"/>
+            <a:ext cx="3017520" cy="274320"/>
+          </a:xfrm>
+          <a:prstGeom prst="rect">
+            <a:avLst/>
+          </a:prstGeom>
+          <a:noFill/>
+        </p:spPr>
+        <p:txBody>
+          <a:bodyPr wrap="square" lIns="0" rIns="0" tIns="0" bIns="0">
+            <a:spAutoFit/>
+          </a:bodyPr>
+          <a:lstStyle/>
+          <a:p>
+            <a:pPr algn="l">
+              <a:spcAft>
+                <a:spcPts val="800"/>
+              </a:spcAft>
+              <a:defRPr sz="1200" b="1">
+                <a:solidFill>
+                  <a:srgbClr val="69E8DA"/>
+                </a:solidFill>
+                <a:latin typeface="Arial"/>
+              </a:defRPr>
+            </a:pPr>
+            <a:r>
+              <a:t>VOICE</a:t>
+            </a:r>
+          </a:p>
+        </p:txBody>
+      </p:sp>
+      <p:sp>
+        <p:nvSpPr>
+          <p:cNvPr id="9" name="TextBox 8"/>
+          <p:cNvSpPr txBox="1"/>
+          <p:nvPr/>
+        </p:nvSpPr>
+        <p:spPr>
+          <a:xfrm>
+            <a:off x="822960" y="3099816"/>
+            <a:ext cx="3054096" cy="868680"/>
+          </a:xfrm>
+          <a:prstGeom prst="rect">
+            <a:avLst/>
+          </a:prstGeom>
+          <a:noFill/>
+        </p:spPr>
+        <p:txBody>
+          <a:bodyPr wrap="square" lIns="0" rIns="0" tIns="0" bIns="0">
+            <a:spAutoFit/>
+          </a:bodyPr>
+          <a:lstStyle/>
+          <a:p>
+            <a:pPr algn="l">
+              <a:spcAft>
+                <a:spcPts val="800"/>
+              </a:spcAft>
+              <a:defRPr sz="2500" b="1">
+                <a:solidFill>
+                  <a:srgbClr val="F3F7FF"/>
+                </a:solidFill>
+                <a:latin typeface="Arial"/>
+              </a:defRPr>
+            </a:pPr>
+            <a:r>
+              <a:t>Question the recording.</a:t>
+            </a:r>
+          </a:p>
+        </p:txBody>
+      </p:sp>
+      <p:sp>
+        <p:nvSpPr>
+          <p:cNvPr id="10" name="TextBox 9"/>
+          <p:cNvSpPr txBox="1"/>
+          <p:nvPr/>
+        </p:nvSpPr>
+        <p:spPr>
+          <a:xfrm>
+            <a:off x="822960" y="4160520"/>
+            <a:ext cx="3054096" cy="941832"/>
+          </a:xfrm>
+          <a:prstGeom prst="rect">
+            <a:avLst/>
+          </a:prstGeom>
+          <a:noFill/>
+        </p:spPr>
+        <p:txBody>
+          <a:bodyPr wrap="square" lIns="0" rIns="0" tIns="0" bIns="0">
+            <a:spAutoFit/>
+          </a:bodyPr>
+          <a:lstStyle/>
+          <a:p>
+            <a:pPr algn="l">
+              <a:spcAft>
+                <a:spcPts val="800"/>
+              </a:spcAft>
+              <a:defRPr sz="1600" b="0">
+                <a:solidFill>
+                  <a:srgbClr val="ADBED5"/>
+                </a:solidFill>
+                <a:latin typeface="Arial"/>
+              </a:defRPr>
+            </a:pPr>
+            <a:r>
+              <a:t>Checks recordings for signs</a:t>
+            </a:r>
+          </a:p>
+          <a:p>
+            <a:pPr algn="l">
+              <a:spcAft>
+                <a:spcPts val="800"/>
+              </a:spcAft>
+              <a:defRPr sz="1600" b="0">
+                <a:solidFill>
+                  <a:srgbClr val="ADBED5"/>
+                </a:solidFill>
+                <a:latin typeface="Arial"/>
+              </a:defRPr>
+            </a:pPr>
+            <a:r>
+              <a:t>of synthetic speech using</a:t>
+            </a:r>
+          </a:p>
+          <a:p>
+            <a:pPr algn="l">
+              <a:spcAft>
+                <a:spcPts val="800"/>
+              </a:spcAft>
+              <a:defRPr sz="1600" b="0">
+                <a:solidFill>
+                  <a:srgbClr val="ADBED5"/>
+                </a:solidFill>
+                <a:latin typeface="Arial"/>
+              </a:defRPr>
+            </a:pPr>
+            <a:r>
+              <a:t>DetectifAI, when configured.</a:t>
+            </a:r>
+          </a:p>
+        </p:txBody>
+      </p:sp>
+      <p:sp>
+        <p:nvSpPr>
+          <p:cNvPr id="11" name="Rounded Rectangle 10"/>
+          <p:cNvSpPr/>
+          <p:nvPr/>
+        </p:nvSpPr>
+        <p:spPr>
+          <a:xfrm>
+            <a:off x="4361688" y="2331720"/>
+            <a:ext cx="3474720" cy="2898648"/>
+          </a:xfrm>
+          <a:prstGeom prst="roundRect">
+            <a:avLst>
+              <a:gd name="adj" fmla="val 12000"/>
+            </a:avLst>
+          </a:prstGeom>
+          <a:solidFill>
+            <a:srgbClr val="13243B"/>
+          </a:solidFill>
+          <a:ln>
+            <a:solidFill>
+              <a:srgbClr val="2A405A"/>
+            </a:solidFill>
+          </a:ln>
+        </p:spPr>
+        <p:style>
+          <a:lnRef idx="1">
+            <a:schemeClr val="accent1"/>
+          </a:lnRef>
+          <a:fillRef idx="3">
+            <a:schemeClr val="accent1"/>
+          </a:fillRef>
+          <a:effectRef idx="2">
+            <a:schemeClr val="accent1"/>
+          </a:effectRef>
+          <a:fontRef idx="minor">
+            <a:schemeClr val="lt1"/>
+          </a:fontRef>
+        </p:style>
+        <p:txBody>
+          <a:bodyPr rtlCol="0" anchor="ctr"/>
+          <a:lstStyle/>
+          <a:p>
+            <a:pPr algn="ctr"/>
+          </a:p>
+        </p:txBody>
+      </p:sp>
+      <p:sp>
+        <p:nvSpPr>
+          <p:cNvPr id="12" name="TextBox 11"/>
+          <p:cNvSpPr txBox="1"/>
+          <p:nvPr/>
+        </p:nvSpPr>
+        <p:spPr>
+          <a:xfrm>
+            <a:off x="4572000" y="2596896"/>
+            <a:ext cx="3017520" cy="274320"/>
+          </a:xfrm>
+          <a:prstGeom prst="rect">
+            <a:avLst/>
+          </a:prstGeom>
+          <a:noFill/>
+        </p:spPr>
+        <p:txBody>
+          <a:bodyPr wrap="square" lIns="0" rIns="0" tIns="0" bIns="0">
+            <a:spAutoFit/>
+          </a:bodyPr>
+          <a:lstStyle/>
+          <a:p>
+            <a:pPr algn="l">
+              <a:spcAft>
+                <a:spcPts val="800"/>
+              </a:spcAft>
+              <a:defRPr sz="1200" b="1">
+                <a:solidFill>
+                  <a:srgbClr val="BEAEFF"/>
+                </a:solidFill>
+                <a:latin typeface="Arial"/>
+              </a:defRPr>
+            </a:pPr>
+            <a:r>
+              <a:t>TEXT</a:t>
+            </a:r>
+          </a:p>
+        </p:txBody>
+      </p:sp>
+      <p:sp>
+        <p:nvSpPr>
+          <p:cNvPr id="13" name="TextBox 12"/>
+          <p:cNvSpPr txBox="1"/>
+          <p:nvPr/>
+        </p:nvSpPr>
+        <p:spPr>
+          <a:xfrm>
+            <a:off x="4572000" y="3099816"/>
+            <a:ext cx="3054096" cy="868680"/>
+          </a:xfrm>
+          <a:prstGeom prst="rect">
+            <a:avLst/>
+          </a:prstGeom>
+          <a:noFill/>
+        </p:spPr>
+        <p:txBody>
+          <a:bodyPr wrap="square" lIns="0" rIns="0" tIns="0" bIns="0">
+            <a:spAutoFit/>
+          </a:bodyPr>
+          <a:lstStyle/>
+          <a:p>
+            <a:pPr algn="l">
+              <a:spcAft>
+                <a:spcPts val="800"/>
+              </a:spcAft>
+              <a:defRPr sz="2500" b="1">
+                <a:solidFill>
+                  <a:srgbClr val="F3F7FF"/>
+                </a:solidFill>
+                <a:latin typeface="Arial"/>
+              </a:defRPr>
+            </a:pPr>
+            <a:r>
+              <a:t>Understand the request.</a:t>
+            </a:r>
+          </a:p>
+        </p:txBody>
+      </p:sp>
+      <p:sp>
+        <p:nvSpPr>
+          <p:cNvPr id="14" name="TextBox 13"/>
+          <p:cNvSpPr txBox="1"/>
+          <p:nvPr/>
+        </p:nvSpPr>
+        <p:spPr>
+          <a:xfrm>
+            <a:off x="4572000" y="4160520"/>
+            <a:ext cx="3054096" cy="941832"/>
+          </a:xfrm>
+          <a:prstGeom prst="rect">
+            <a:avLst/>
+          </a:prstGeom>
+          <a:noFill/>
+        </p:spPr>
+        <p:txBody>
+          <a:bodyPr wrap="square" lIns="0" rIns="0" tIns="0" bIns="0">
+            <a:spAutoFit/>
+          </a:bodyPr>
+          <a:lstStyle/>
+          <a:p>
+            <a:pPr algn="l">
+              <a:spcAft>
+                <a:spcPts val="800"/>
+              </a:spcAft>
+              <a:defRPr sz="1600" b="0">
+                <a:solidFill>
+                  <a:srgbClr val="ADBED5"/>
+                </a:solidFill>
+                <a:latin typeface="Arial"/>
+              </a:defRPr>
+            </a:pPr>
+            <a:r>
+              <a:t>Checks job offers, banking</a:t>
+            </a:r>
+          </a:p>
+          <a:p>
+            <a:pPr algn="l">
+              <a:spcAft>
+                <a:spcPts val="800"/>
+              </a:spcAft>
+              <a:defRPr sz="1600" b="0">
+                <a:solidFill>
+                  <a:srgbClr val="ADBED5"/>
+                </a:solidFill>
+                <a:latin typeface="Arial"/>
+              </a:defRPr>
+            </a:pPr>
+            <a:r>
+              <a:t>messages, payment demands</a:t>
+            </a:r>
+          </a:p>
+          <a:p>
+            <a:pPr algn="l">
+              <a:spcAft>
+                <a:spcPts val="800"/>
+              </a:spcAft>
+              <a:defRPr sz="1600" b="0">
+                <a:solidFill>
+                  <a:srgbClr val="ADBED5"/>
+                </a:solidFill>
+                <a:latin typeface="Arial"/>
+              </a:defRPr>
+            </a:pPr>
+            <a:r>
+              <a:t>and other suspicious text.</a:t>
+            </a:r>
+          </a:p>
+        </p:txBody>
+      </p:sp>
+      <p:sp>
+        <p:nvSpPr>
+          <p:cNvPr id="15" name="Rounded Rectangle 14"/>
+          <p:cNvSpPr/>
+          <p:nvPr/>
+        </p:nvSpPr>
+        <p:spPr>
+          <a:xfrm>
+            <a:off x="8110727" y="2331720"/>
+            <a:ext cx="3474720" cy="2898648"/>
+          </a:xfrm>
+          <a:prstGeom prst="roundRect">
+            <a:avLst>
+              <a:gd name="adj" fmla="val 12000"/>
+            </a:avLst>
+          </a:prstGeom>
+          <a:solidFill>
+            <a:srgbClr val="13243B"/>
+          </a:solidFill>
+          <a:ln>
+            <a:solidFill>
+              <a:srgbClr val="2A405A"/>
+            </a:solidFill>
+          </a:ln>
+        </p:spPr>
+        <p:style>
+          <a:lnRef idx="1">
+            <a:schemeClr val="accent1"/>
+          </a:lnRef>
+          <a:fillRef idx="3">
+            <a:schemeClr val="accent1"/>
+          </a:fillRef>
+          <a:effectRef idx="2">
+            <a:schemeClr val="accent1"/>
+          </a:effectRef>
+          <a:fontRef idx="minor">
+            <a:schemeClr val="lt1"/>
+          </a:fontRef>
+        </p:style>
+        <p:txBody>
+          <a:bodyPr rtlCol="0" anchor="ctr"/>
+          <a:lstStyle/>
+          <a:p>
+            <a:pPr algn="ctr"/>
+          </a:p>
+        </p:txBody>
+      </p:sp>
+      <p:sp>
+        <p:nvSpPr>
+          <p:cNvPr id="16" name="TextBox 15"/>
+          <p:cNvSpPr txBox="1"/>
+          <p:nvPr/>
+        </p:nvSpPr>
+        <p:spPr>
+          <a:xfrm>
+            <a:off x="8321040" y="2596896"/>
+            <a:ext cx="3017520" cy="274320"/>
+          </a:xfrm>
+          <a:prstGeom prst="rect">
+            <a:avLst/>
+          </a:prstGeom>
+          <a:noFill/>
+        </p:spPr>
+        <p:txBody>
+          <a:bodyPr wrap="square" lIns="0" rIns="0" tIns="0" bIns="0">
+            <a:spAutoFit/>
+          </a:bodyPr>
+          <a:lstStyle/>
+          <a:p>
+            <a:pPr algn="l">
+              <a:spcAft>
+                <a:spcPts val="800"/>
+              </a:spcAft>
+              <a:defRPr sz="1200" b="1">
+                <a:solidFill>
+                  <a:srgbClr val="FFD69D"/>
+                </a:solidFill>
+                <a:latin typeface="Arial"/>
+              </a:defRPr>
+            </a:pPr>
+            <a:r>
+              <a:t>COMMUNITY</a:t>
+            </a:r>
+          </a:p>
+        </p:txBody>
+      </p:sp>
+      <p:sp>
+        <p:nvSpPr>
+          <p:cNvPr id="17" name="TextBox 16"/>
+          <p:cNvSpPr txBox="1"/>
+          <p:nvPr/>
+        </p:nvSpPr>
+        <p:spPr>
+          <a:xfrm>
+            <a:off x="8321040" y="3099816"/>
+            <a:ext cx="3054096" cy="868680"/>
+          </a:xfrm>
+          <a:prstGeom prst="rect">
+            <a:avLst/>
+          </a:prstGeom>
+          <a:noFill/>
+        </p:spPr>
+        <p:txBody>
+          <a:bodyPr wrap="square" lIns="0" rIns="0" tIns="0" bIns="0">
+            <a:spAutoFit/>
+          </a:bodyPr>
+          <a:lstStyle/>
+          <a:p>
+            <a:pPr algn="l">
+              <a:spcAft>
+                <a:spcPts val="800"/>
+              </a:spcAft>
+              <a:defRPr sz="2500" b="1">
+                <a:solidFill>
+                  <a:srgbClr val="F3F7FF"/>
+                </a:solidFill>
+                <a:latin typeface="Arial"/>
+              </a:defRPr>
+            </a:pPr>
+            <a:r>
+              <a:t>Learn from reports.</a:t>
+            </a:r>
+          </a:p>
+        </p:txBody>
+      </p:sp>
+      <p:sp>
+        <p:nvSpPr>
+          <p:cNvPr id="18" name="TextBox 17"/>
+          <p:cNvSpPr txBox="1"/>
+          <p:nvPr/>
+        </p:nvSpPr>
+        <p:spPr>
+          <a:xfrm>
+            <a:off x="8321040" y="4160520"/>
+            <a:ext cx="3054096" cy="941832"/>
+          </a:xfrm>
+          <a:prstGeom prst="rect">
+            <a:avLst/>
+          </a:prstGeom>
+          <a:noFill/>
+        </p:spPr>
+        <p:txBody>
+          <a:bodyPr wrap="square" lIns="0" rIns="0" tIns="0" bIns="0">
+            <a:spAutoFit/>
+          </a:bodyPr>
+          <a:lstStyle/>
+          <a:p>
+            <a:pPr algn="l">
+              <a:spcAft>
+                <a:spcPts val="800"/>
+              </a:spcAft>
+              <a:defRPr sz="1600" b="0">
+                <a:solidFill>
+                  <a:srgbClr val="ADBED5"/>
+                </a:solidFill>
+                <a:latin typeface="Arial"/>
+              </a:defRPr>
+            </a:pPr>
+            <a:r>
+              <a:t>Search phone report totals</a:t>
+            </a:r>
+          </a:p>
+          <a:p>
+            <a:pPr algn="l">
+              <a:spcAft>
+                <a:spcPts val="800"/>
+              </a:spcAft>
+              <a:defRPr sz="1600" b="0">
+                <a:solidFill>
+                  <a:srgbClr val="ADBED5"/>
+                </a:solidFill>
+                <a:latin typeface="Arial"/>
+              </a:defRPr>
+            </a:pPr>
+            <a:r>
+              <a:t>and share suspicious-call</a:t>
+            </a:r>
+          </a:p>
+          <a:p>
+            <a:pPr algn="l">
+              <a:spcAft>
+                <a:spcPts val="800"/>
+              </a:spcAft>
+              <a:defRPr sz="1600" b="0">
+                <a:solidFill>
+                  <a:srgbClr val="ADBED5"/>
+                </a:solidFill>
+                <a:latin typeface="Arial"/>
+              </a:defRPr>
+            </a:pPr>
+            <a:r>
+              <a:t>experiences with others.</a:t>
+            </a:r>
+          </a:p>
+        </p:txBody>
+      </p:sp>
+      <p:sp>
+        <p:nvSpPr>
+          <p:cNvPr id="19" name="TextBox 18"/>
+          <p:cNvSpPr txBox="1"/>
+          <p:nvPr/>
+        </p:nvSpPr>
+        <p:spPr>
+          <a:xfrm>
+            <a:off x="667512" y="5650992"/>
+            <a:ext cx="10881360" cy="438912"/>
+          </a:xfrm>
+          <a:prstGeom prst="rect">
+            <a:avLst/>
+          </a:prstGeom>
+          <a:noFill/>
+        </p:spPr>
+        <p:txBody>
+          <a:bodyPr wrap="square" lIns="0" rIns="0" tIns="0" bIns="0">
+            <a:spAutoFit/>
+          </a:bodyPr>
+          <a:lstStyle/>
+          <a:p>
+            <a:pPr algn="l">
+              <a:spcAft>
+                <a:spcPts val="800"/>
+              </a:spcAft>
+              <a:defRPr sz="2400" b="1">
+                <a:solidFill>
+                  <a:srgbClr val="F3F7FF"/>
+                </a:solidFill>
+                <a:latin typeface="Arial"/>
+              </a:defRPr>
+            </a:pPr>
+            <a:r>
+              <a:t>Clear explanations. No numerical scam probabilities.</a:t>
             </a:r>
           </a:p>
         </p:txBody>
@@ -5571,7 +6495,7 @@
               </a:defRPr>
             </a:pPr>
             <a:r>
-              <a:t>03 / 05</a:t>
+              <a:t>04 / 06</a:t>
             </a:r>
           </a:p>
         </p:txBody>
@@ -6324,7 +7248,7 @@
               </a:defRPr>
             </a:pPr>
             <a:r>
-              <a:t>04 / 05</a:t>
+              <a:t>05 / 06</a:t>
             </a:r>
           </a:p>
         </p:txBody>
@@ -7157,7 +8081,7 @@
               </a:defRPr>
             </a:pPr>
             <a:r>
-              <a:t>05 / 05</a:t>
+              <a:t>06 / 06</a:t>
             </a:r>
           </a:p>
         </p:txBody>

</xml_diff>

<commit_message>
Remove How it works slide from EchoGuard presentation
</commit_message>
<xml_diff>
--- a/presentation/EchoGuard.pptx
+++ b/presentation/EchoGuard.pptx
@@ -6,7 +6,6 @@
   </p:sldMasterIdLst>
   <p:sldIdLst>
     <p:sldId id="256" r:id="rId7"/>
-    <p:sldId id="257" r:id="rId9"/>
     <p:sldId id="258" r:id="rId10"/>
     <p:sldId id="259" r:id="rId11"/>
     <p:sldId id="260" r:id="rId12"/>
@@ -538,82 +537,6 @@
 </p:notes>
 </file>
 
-<file path=ppt/notesSlides/notesSlide2.xml><?xml version="1.0" encoding="utf-8"?>
-<p:notes xmlns:a="http://schemas.openxmlformats.org/drawingml/2006/main" xmlns:p="http://schemas.openxmlformats.org/presentationml/2006/main" xmlns:r="http://schemas.openxmlformats.org/officeDocument/2006/relationships">
-  <p:cSld>
-    <p:spTree>
-      <p:nvGrpSpPr>
-        <p:cNvPr id="1" name=""/>
-        <p:cNvGrpSpPr/>
-        <p:nvPr/>
-      </p:nvGrpSpPr>
-      <p:grpSpPr>
-        <a:xfrm>
-          <a:off x="0" y="0"/>
-          <a:ext cx="0" cy="0"/>
-          <a:chOff x="0" y="0"/>
-          <a:chExt cx="0" cy="0"/>
-        </a:xfrm>
-      </p:grpSpPr>
-      <p:sp>
-        <p:nvSpPr>
-          <p:cNvPr id="2" name="Slide Image Placeholder 1"/>
-          <p:cNvSpPr>
-            <a:spLocks noGrp="1"/>
-          </p:cNvSpPr>
-          <p:nvPr>
-            <p:ph type="sldImg" idx="2"/>
-          </p:nvPr>
-        </p:nvSpPr>
-        <p:spPr/>
-      </p:sp>
-      <p:sp>
-        <p:nvSpPr>
-          <p:cNvPr id="3" name="Notes Placeholder 2"/>
-          <p:cNvSpPr>
-            <a:spLocks noGrp="1"/>
-          </p:cNvSpPr>
-          <p:nvPr>
-            <p:ph type="body" idx="3" sz="quarter"/>
-          </p:nvPr>
-        </p:nvSpPr>
-        <p:spPr/>
-        <p:txBody>
-          <a:bodyPr/>
-          <a:lstStyle/>
-          <a:p>
-            <a:r>
-              <a:t>TARGET: 00:25–01:00 | 35 seconds</a:t>
-            </a:r>
-          </a:p>
-          <a:p/>
-          <a:p>
-            <a:r>
-              <a:t>First, the user chooses what they have: a recording, a suspicious message, or a phone number. EchoGuard runs the relevant check and presents the evidence with a clear explanation. The user then verifies the request through an independent official channel. Today, audio and text are separate inputs: uploading audio does not automatically create a transcript. If a service is unavailable, we show that clearly instead of displaying a successful or safe result.</a:t>
-            </a:r>
-          </a:p>
-        </p:txBody>
-      </p:sp>
-      <p:sp>
-        <p:nvSpPr>
-          <p:cNvPr id="4" name="Slide Number Placeholder 3"/>
-          <p:cNvSpPr>
-            <a:spLocks noGrp="1"/>
-          </p:cNvSpPr>
-          <p:nvPr>
-            <p:ph type="sldNum" idx="5" sz="quarter"/>
-          </p:nvPr>
-        </p:nvSpPr>
-        <p:spPr/>
-      </p:sp>
-    </p:spTree>
-  </p:cSld>
-  <p:clrMapOvr>
-    <a:masterClrMapping/>
-  </p:clrMapOvr>
-</p:notes>
-</file>
-
 <file path=ppt/notesSlides/notesSlide3.xml><?xml version="1.0" encoding="utf-8"?>
 <p:notes xmlns:a="http://schemas.openxmlformats.org/drawingml/2006/main" xmlns:p="http://schemas.openxmlformats.org/presentationml/2006/main" xmlns:r="http://schemas.openxmlformats.org/officeDocument/2006/relationships">
   <p:cSld>
@@ -659,7 +582,7 @@
           <a:lstStyle/>
           <a:p>
             <a:r>
-              <a:t>TARGET: 01:00–01:35 | 35 seconds</a:t>
+              <a:t>TARGET: 00:25–01:10 | 45 seconds</a:t>
             </a:r>
           </a:p>
           <a:p/>
@@ -735,7 +658,7 @@
           <a:lstStyle/>
           <a:p>
             <a:r>
-              <a:t>TARGET: 01:35–02:30 | 55 seconds</a:t>
+              <a:t>TARGET: 01:10–02:10 | 60 seconds</a:t>
             </a:r>
           </a:p>
           <a:p/>
@@ -811,7 +734,7 @@
           <a:lstStyle/>
           <a:p>
             <a:r>
-              <a:t>TARGET: 02:30–03:15 | 45 seconds</a:t>
+              <a:t>TARGET: 02:10–03:10 | 60 seconds</a:t>
             </a:r>
           </a:p>
           <a:p/>
@@ -887,7 +810,7 @@
           <a:lstStyle/>
           <a:p>
             <a:r>
-              <a:t>TARGET: 03:15–04:00 | 45 seconds</a:t>
+              <a:t>TARGET: 03:10–04:00 | 50 seconds</a:t>
             </a:r>
           </a:p>
           <a:p/>
@@ -4093,7 +4016,7 @@
               </a:defRPr>
             </a:pPr>
             <a:r>
-              <a:t>01 / 06</a:t>
+              <a:t>01 / 05</a:t>
             </a:r>
           </a:p>
         </p:txBody>
@@ -4454,985 +4377,6 @@
           </a:prstGeom>
         </p:spPr>
       </p:pic>
-    </p:spTree>
-  </p:cSld>
-  <p:clrMapOvr>
-    <a:masterClrMapping/>
-  </p:clrMapOvr>
-  <p:transition spd="med" advClick="1">
-    <p:fade/>
-  </p:transition>
-</p:sld>
-</file>
-
-<file path=ppt/slides/slide2.xml><?xml version="1.0" encoding="utf-8"?>
-<p:sld xmlns:a="http://schemas.openxmlformats.org/drawingml/2006/main" xmlns:p="http://schemas.openxmlformats.org/presentationml/2006/main" xmlns:r="http://schemas.openxmlformats.org/officeDocument/2006/relationships">
-  <p:cSld>
-    <p:bg>
-      <p:bgPr>
-        <a:solidFill>
-          <a:srgbClr val="0A1426"/>
-        </a:solidFill>
-        <a:effectLst/>
-      </p:bgPr>
-    </p:bg>
-    <p:spTree>
-      <p:nvGrpSpPr>
-        <p:cNvPr id="1" name=""/>
-        <p:cNvGrpSpPr/>
-        <p:nvPr/>
-      </p:nvGrpSpPr>
-      <p:grpSpPr/>
-      <p:sp>
-        <p:nvSpPr>
-          <p:cNvPr id="2" name="TextBox 1"/>
-          <p:cNvSpPr txBox="1"/>
-          <p:nvPr/>
-        </p:nvSpPr>
-        <p:spPr>
-          <a:xfrm>
-            <a:off x="594360" y="402336"/>
-            <a:ext cx="10972800" cy="274320"/>
-          </a:xfrm>
-          <a:prstGeom prst="rect">
-            <a:avLst/>
-          </a:prstGeom>
-          <a:noFill/>
-        </p:spPr>
-        <p:txBody>
-          <a:bodyPr wrap="square" lIns="0" rIns="0" tIns="0" bIns="0">
-            <a:spAutoFit/>
-          </a:bodyPr>
-          <a:lstStyle/>
-          <a:p>
-            <a:pPr algn="l">
-              <a:spcAft>
-                <a:spcPts val="800"/>
-              </a:spcAft>
-              <a:defRPr sz="1100" b="1">
-                <a:solidFill>
-                  <a:srgbClr val="69E8DA"/>
-                </a:solidFill>
-                <a:latin typeface="Arial"/>
-              </a:defRPr>
-            </a:pPr>
-            <a:r>
-              <a:t>FROM INPUT TO INFORMED ACTION</a:t>
-            </a:r>
-          </a:p>
-        </p:txBody>
-      </p:sp>
-      <p:sp>
-        <p:nvSpPr>
-          <p:cNvPr id="3" name="TextBox 2"/>
-          <p:cNvSpPr txBox="1"/>
-          <p:nvPr/>
-        </p:nvSpPr>
-        <p:spPr>
-          <a:xfrm>
-            <a:off x="594360" y="932688"/>
-            <a:ext cx="10972800" cy="914400"/>
-          </a:xfrm>
-          <a:prstGeom prst="rect">
-            <a:avLst/>
-          </a:prstGeom>
-          <a:noFill/>
-        </p:spPr>
-        <p:txBody>
-          <a:bodyPr wrap="square" lIns="0" rIns="0" tIns="0" bIns="0">
-            <a:spAutoFit/>
-          </a:bodyPr>
-          <a:lstStyle/>
-          <a:p>
-            <a:pPr algn="l">
-              <a:spcAft>
-                <a:spcPts val="800"/>
-              </a:spcAft>
-              <a:defRPr sz="3600" b="1">
-                <a:solidFill>
-                  <a:srgbClr val="F3F7FF"/>
-                </a:solidFill>
-                <a:latin typeface="Arial"/>
-              </a:defRPr>
-            </a:pPr>
-            <a:r>
-              <a:t>How it works</a:t>
-            </a:r>
-          </a:p>
-        </p:txBody>
-      </p:sp>
-      <p:cxnSp>
-        <p:nvCxnSpPr>
-          <p:cNvPr id="4" name="Connector 3"/>
-          <p:cNvCxnSpPr/>
-          <p:nvPr/>
-        </p:nvCxnSpPr>
-        <p:spPr>
-          <a:xfrm>
-            <a:off x="594360" y="6419088"/>
-            <a:ext cx="10972800" cy="0"/>
-          </a:xfrm>
-          <a:prstGeom prst="line">
-            <a:avLst/>
-          </a:prstGeom>
-          <a:ln w="15240">
-            <a:solidFill>
-              <a:srgbClr val="2A405A"/>
-            </a:solidFill>
-          </a:ln>
-        </p:spPr>
-        <p:style>
-          <a:lnRef idx="2">
-            <a:schemeClr val="accent1"/>
-          </a:lnRef>
-          <a:fillRef idx="0">
-            <a:schemeClr val="accent1"/>
-          </a:fillRef>
-          <a:effectRef idx="1">
-            <a:schemeClr val="accent1"/>
-          </a:effectRef>
-          <a:fontRef idx="minor">
-            <a:schemeClr val="tx1"/>
-          </a:fontRef>
-        </p:style>
-      </p:cxnSp>
-      <p:sp>
-        <p:nvSpPr>
-          <p:cNvPr id="5" name="TextBox 4"/>
-          <p:cNvSpPr txBox="1"/>
-          <p:nvPr/>
-        </p:nvSpPr>
-        <p:spPr>
-          <a:xfrm>
-            <a:off x="621792" y="6556248"/>
-            <a:ext cx="8229600" cy="182880"/>
-          </a:xfrm>
-          <a:prstGeom prst="rect">
-            <a:avLst/>
-          </a:prstGeom>
-          <a:noFill/>
-        </p:spPr>
-        <p:txBody>
-          <a:bodyPr wrap="square" lIns="0" rIns="0" tIns="0" bIns="0">
-            <a:spAutoFit/>
-          </a:bodyPr>
-          <a:lstStyle/>
-          <a:p>
-            <a:pPr algn="l">
-              <a:spcAft>
-                <a:spcPts val="800"/>
-              </a:spcAft>
-              <a:defRPr sz="1000" b="1">
-                <a:solidFill>
-                  <a:srgbClr val="ADBED5"/>
-                </a:solidFill>
-                <a:latin typeface="Arial"/>
-              </a:defRPr>
-            </a:pPr>
-            <a:r>
-              <a:t>ECHOGUARD  /  UNCLONE AI</a:t>
-            </a:r>
-          </a:p>
-        </p:txBody>
-      </p:sp>
-      <p:sp>
-        <p:nvSpPr>
-          <p:cNvPr id="6" name="TextBox 5"/>
-          <p:cNvSpPr txBox="1"/>
-          <p:nvPr/>
-        </p:nvSpPr>
-        <p:spPr>
-          <a:xfrm>
-            <a:off x="10607040" y="6528816"/>
-            <a:ext cx="960120" cy="228600"/>
-          </a:xfrm>
-          <a:prstGeom prst="rect">
-            <a:avLst/>
-          </a:prstGeom>
-          <a:noFill/>
-        </p:spPr>
-        <p:txBody>
-          <a:bodyPr wrap="square" lIns="0" rIns="0" tIns="0" bIns="0">
-            <a:spAutoFit/>
-          </a:bodyPr>
-          <a:lstStyle/>
-          <a:p>
-            <a:pPr algn="r">
-              <a:spcAft>
-                <a:spcPts val="800"/>
-              </a:spcAft>
-              <a:defRPr sz="1100" b="1">
-                <a:solidFill>
-                  <a:srgbClr val="69E8DA"/>
-                </a:solidFill>
-                <a:latin typeface="Arial"/>
-              </a:defRPr>
-            </a:pPr>
-            <a:r>
-              <a:t>02 / 06</a:t>
-            </a:r>
-          </a:p>
-        </p:txBody>
-      </p:sp>
-      <p:sp>
-        <p:nvSpPr>
-          <p:cNvPr id="7" name="Rounded Rectangle 6"/>
-          <p:cNvSpPr/>
-          <p:nvPr/>
-        </p:nvSpPr>
-        <p:spPr>
-          <a:xfrm>
-            <a:off x="612648" y="2194560"/>
-            <a:ext cx="5458968" cy="1417320"/>
-          </a:xfrm>
-          <a:prstGeom prst="roundRect">
-            <a:avLst>
-              <a:gd name="adj" fmla="val 12000"/>
-            </a:avLst>
-          </a:prstGeom>
-          <a:solidFill>
-            <a:srgbClr val="13243B"/>
-          </a:solidFill>
-          <a:ln>
-            <a:solidFill>
-              <a:srgbClr val="2A405A"/>
-            </a:solidFill>
-          </a:ln>
-        </p:spPr>
-        <p:style>
-          <a:lnRef idx="1">
-            <a:schemeClr val="accent1"/>
-          </a:lnRef>
-          <a:fillRef idx="3">
-            <a:schemeClr val="accent1"/>
-          </a:fillRef>
-          <a:effectRef idx="2">
-            <a:schemeClr val="accent1"/>
-          </a:effectRef>
-          <a:fontRef idx="minor">
-            <a:schemeClr val="lt1"/>
-          </a:fontRef>
-        </p:style>
-        <p:txBody>
-          <a:bodyPr rtlCol="0" anchor="ctr"/>
-          <a:lstStyle/>
-          <a:p>
-            <a:pPr algn="ctr"/>
-          </a:p>
-        </p:txBody>
-      </p:sp>
-      <p:sp>
-        <p:nvSpPr>
-          <p:cNvPr id="8" name="TextBox 7"/>
-          <p:cNvSpPr txBox="1"/>
-          <p:nvPr/>
-        </p:nvSpPr>
-        <p:spPr>
-          <a:xfrm>
-            <a:off x="813816" y="2395728"/>
-            <a:ext cx="640080" cy="457200"/>
-          </a:xfrm>
-          <a:prstGeom prst="rect">
-            <a:avLst/>
-          </a:prstGeom>
-          <a:noFill/>
-        </p:spPr>
-        <p:txBody>
-          <a:bodyPr wrap="square" lIns="0" rIns="0" tIns="0" bIns="0">
-            <a:spAutoFit/>
-          </a:bodyPr>
-          <a:lstStyle/>
-          <a:p>
-            <a:pPr algn="l">
-              <a:spcAft>
-                <a:spcPts val="800"/>
-              </a:spcAft>
-              <a:defRPr sz="3000" b="1">
-                <a:solidFill>
-                  <a:srgbClr val="69E8DA"/>
-                </a:solidFill>
-                <a:latin typeface="Arial"/>
-              </a:defRPr>
-            </a:pPr>
-            <a:r>
-              <a:t>01</a:t>
-            </a:r>
-          </a:p>
-        </p:txBody>
-      </p:sp>
-      <p:sp>
-        <p:nvSpPr>
-          <p:cNvPr id="9" name="TextBox 8"/>
-          <p:cNvSpPr txBox="1"/>
-          <p:nvPr/>
-        </p:nvSpPr>
-        <p:spPr>
-          <a:xfrm>
-            <a:off x="1618488" y="2404872"/>
-            <a:ext cx="4114800" cy="329184"/>
-          </a:xfrm>
-          <a:prstGeom prst="rect">
-            <a:avLst/>
-          </a:prstGeom>
-          <a:noFill/>
-        </p:spPr>
-        <p:txBody>
-          <a:bodyPr wrap="square" lIns="0" rIns="0" tIns="0" bIns="0">
-            <a:spAutoFit/>
-          </a:bodyPr>
-          <a:lstStyle/>
-          <a:p>
-            <a:pPr algn="l">
-              <a:spcAft>
-                <a:spcPts val="800"/>
-              </a:spcAft>
-              <a:defRPr sz="1700" b="1">
-                <a:solidFill>
-                  <a:srgbClr val="F3F7FF"/>
-                </a:solidFill>
-                <a:latin typeface="Arial"/>
-              </a:defRPr>
-            </a:pPr>
-            <a:r>
-              <a:t>CHOOSE YOUR INPUT</a:t>
-            </a:r>
-          </a:p>
-        </p:txBody>
-      </p:sp>
-      <p:sp>
-        <p:nvSpPr>
-          <p:cNvPr id="10" name="TextBox 9"/>
-          <p:cNvSpPr txBox="1"/>
-          <p:nvPr/>
-        </p:nvSpPr>
-        <p:spPr>
-          <a:xfrm>
-            <a:off x="1618488" y="2907791"/>
-            <a:ext cx="4114800" cy="594360"/>
-          </a:xfrm>
-          <a:prstGeom prst="rect">
-            <a:avLst/>
-          </a:prstGeom>
-          <a:noFill/>
-        </p:spPr>
-        <p:txBody>
-          <a:bodyPr wrap="square" lIns="0" rIns="0" tIns="0" bIns="0">
-            <a:spAutoFit/>
-          </a:bodyPr>
-          <a:lstStyle/>
-          <a:p>
-            <a:pPr algn="l">
-              <a:spcAft>
-                <a:spcPts val="800"/>
-              </a:spcAft>
-              <a:defRPr sz="1700" b="0">
-                <a:solidFill>
-                  <a:srgbClr val="ADBED5"/>
-                </a:solidFill>
-                <a:latin typeface="Arial"/>
-              </a:defRPr>
-            </a:pPr>
-            <a:r>
-              <a:t>Upload a recording, paste text,</a:t>
-            </a:r>
-          </a:p>
-          <a:p>
-            <a:pPr algn="l">
-              <a:spcAft>
-                <a:spcPts val="800"/>
-              </a:spcAft>
-              <a:defRPr sz="1700" b="0">
-                <a:solidFill>
-                  <a:srgbClr val="ADBED5"/>
-                </a:solidFill>
-                <a:latin typeface="Arial"/>
-              </a:defRPr>
-            </a:pPr>
-            <a:r>
-              <a:t>or enter a phone number.</a:t>
-            </a:r>
-          </a:p>
-        </p:txBody>
-      </p:sp>
-      <p:sp>
-        <p:nvSpPr>
-          <p:cNvPr id="11" name="Rounded Rectangle 10"/>
-          <p:cNvSpPr/>
-          <p:nvPr/>
-        </p:nvSpPr>
-        <p:spPr>
-          <a:xfrm>
-            <a:off x="6227064" y="2194560"/>
-            <a:ext cx="5458968" cy="1417320"/>
-          </a:xfrm>
-          <a:prstGeom prst="roundRect">
-            <a:avLst>
-              <a:gd name="adj" fmla="val 12000"/>
-            </a:avLst>
-          </a:prstGeom>
-          <a:solidFill>
-            <a:srgbClr val="13243B"/>
-          </a:solidFill>
-          <a:ln>
-            <a:solidFill>
-              <a:srgbClr val="2A405A"/>
-            </a:solidFill>
-          </a:ln>
-        </p:spPr>
-        <p:style>
-          <a:lnRef idx="1">
-            <a:schemeClr val="accent1"/>
-          </a:lnRef>
-          <a:fillRef idx="3">
-            <a:schemeClr val="accent1"/>
-          </a:fillRef>
-          <a:effectRef idx="2">
-            <a:schemeClr val="accent1"/>
-          </a:effectRef>
-          <a:fontRef idx="minor">
-            <a:schemeClr val="lt1"/>
-          </a:fontRef>
-        </p:style>
-        <p:txBody>
-          <a:bodyPr rtlCol="0" anchor="ctr"/>
-          <a:lstStyle/>
-          <a:p>
-            <a:pPr algn="ctr"/>
-          </a:p>
-        </p:txBody>
-      </p:sp>
-      <p:sp>
-        <p:nvSpPr>
-          <p:cNvPr id="12" name="TextBox 11"/>
-          <p:cNvSpPr txBox="1"/>
-          <p:nvPr/>
-        </p:nvSpPr>
-        <p:spPr>
-          <a:xfrm>
-            <a:off x="6428231" y="2395728"/>
-            <a:ext cx="640080" cy="457200"/>
-          </a:xfrm>
-          <a:prstGeom prst="rect">
-            <a:avLst/>
-          </a:prstGeom>
-          <a:noFill/>
-        </p:spPr>
-        <p:txBody>
-          <a:bodyPr wrap="square" lIns="0" rIns="0" tIns="0" bIns="0">
-            <a:spAutoFit/>
-          </a:bodyPr>
-          <a:lstStyle/>
-          <a:p>
-            <a:pPr algn="l">
-              <a:spcAft>
-                <a:spcPts val="800"/>
-              </a:spcAft>
-              <a:defRPr sz="3000" b="1">
-                <a:solidFill>
-                  <a:srgbClr val="BEAEFF"/>
-                </a:solidFill>
-                <a:latin typeface="Arial"/>
-              </a:defRPr>
-            </a:pPr>
-            <a:r>
-              <a:t>02</a:t>
-            </a:r>
-          </a:p>
-        </p:txBody>
-      </p:sp>
-      <p:sp>
-        <p:nvSpPr>
-          <p:cNvPr id="13" name="TextBox 12"/>
-          <p:cNvSpPr txBox="1"/>
-          <p:nvPr/>
-        </p:nvSpPr>
-        <p:spPr>
-          <a:xfrm>
-            <a:off x="7232904" y="2404872"/>
-            <a:ext cx="4114800" cy="329184"/>
-          </a:xfrm>
-          <a:prstGeom prst="rect">
-            <a:avLst/>
-          </a:prstGeom>
-          <a:noFill/>
-        </p:spPr>
-        <p:txBody>
-          <a:bodyPr wrap="square" lIns="0" rIns="0" tIns="0" bIns="0">
-            <a:spAutoFit/>
-          </a:bodyPr>
-          <a:lstStyle/>
-          <a:p>
-            <a:pPr algn="l">
-              <a:spcAft>
-                <a:spcPts val="800"/>
-              </a:spcAft>
-              <a:defRPr sz="1700" b="1">
-                <a:solidFill>
-                  <a:srgbClr val="F3F7FF"/>
-                </a:solidFill>
-                <a:latin typeface="Arial"/>
-              </a:defRPr>
-            </a:pPr>
-            <a:r>
-              <a:t>RUN THE RIGHT CHECK</a:t>
-            </a:r>
-          </a:p>
-        </p:txBody>
-      </p:sp>
-      <p:sp>
-        <p:nvSpPr>
-          <p:cNvPr id="14" name="TextBox 13"/>
-          <p:cNvSpPr txBox="1"/>
-          <p:nvPr/>
-        </p:nvSpPr>
-        <p:spPr>
-          <a:xfrm>
-            <a:off x="7232904" y="2907791"/>
-            <a:ext cx="4114800" cy="594360"/>
-          </a:xfrm>
-          <a:prstGeom prst="rect">
-            <a:avLst/>
-          </a:prstGeom>
-          <a:noFill/>
-        </p:spPr>
-        <p:txBody>
-          <a:bodyPr wrap="square" lIns="0" rIns="0" tIns="0" bIns="0">
-            <a:spAutoFit/>
-          </a:bodyPr>
-          <a:lstStyle/>
-          <a:p>
-            <a:pPr algn="l">
-              <a:spcAft>
-                <a:spcPts val="800"/>
-              </a:spcAft>
-              <a:defRPr sz="1700" b="0">
-                <a:solidFill>
-                  <a:srgbClr val="ADBED5"/>
-                </a:solidFill>
-                <a:latin typeface="Arial"/>
-              </a:defRPr>
-            </a:pPr>
-            <a:r>
-              <a:t>Voice, text and community</a:t>
-            </a:r>
-          </a:p>
-          <a:p>
-            <a:pPr algn="l">
-              <a:spcAft>
-                <a:spcPts val="800"/>
-              </a:spcAft>
-              <a:defRPr sz="1700" b="0">
-                <a:solidFill>
-                  <a:srgbClr val="ADBED5"/>
-                </a:solidFill>
-                <a:latin typeface="Arial"/>
-              </a:defRPr>
-            </a:pPr>
-            <a:r>
-              <a:t>checks work independently.</a:t>
-            </a:r>
-          </a:p>
-        </p:txBody>
-      </p:sp>
-      <p:sp>
-        <p:nvSpPr>
-          <p:cNvPr id="15" name="Rounded Rectangle 14"/>
-          <p:cNvSpPr/>
-          <p:nvPr/>
-        </p:nvSpPr>
-        <p:spPr>
-          <a:xfrm>
-            <a:off x="612648" y="3886200"/>
-            <a:ext cx="5458968" cy="1417320"/>
-          </a:xfrm>
-          <a:prstGeom prst="roundRect">
-            <a:avLst>
-              <a:gd name="adj" fmla="val 12000"/>
-            </a:avLst>
-          </a:prstGeom>
-          <a:solidFill>
-            <a:srgbClr val="13243B"/>
-          </a:solidFill>
-          <a:ln>
-            <a:solidFill>
-              <a:srgbClr val="2A405A"/>
-            </a:solidFill>
-          </a:ln>
-        </p:spPr>
-        <p:style>
-          <a:lnRef idx="1">
-            <a:schemeClr val="accent1"/>
-          </a:lnRef>
-          <a:fillRef idx="3">
-            <a:schemeClr val="accent1"/>
-          </a:fillRef>
-          <a:effectRef idx="2">
-            <a:schemeClr val="accent1"/>
-          </a:effectRef>
-          <a:fontRef idx="minor">
-            <a:schemeClr val="lt1"/>
-          </a:fontRef>
-        </p:style>
-        <p:txBody>
-          <a:bodyPr rtlCol="0" anchor="ctr"/>
-          <a:lstStyle/>
-          <a:p>
-            <a:pPr algn="ctr"/>
-          </a:p>
-        </p:txBody>
-      </p:sp>
-      <p:sp>
-        <p:nvSpPr>
-          <p:cNvPr id="16" name="TextBox 15"/>
-          <p:cNvSpPr txBox="1"/>
-          <p:nvPr/>
-        </p:nvSpPr>
-        <p:spPr>
-          <a:xfrm>
-            <a:off x="813816" y="4087368"/>
-            <a:ext cx="640080" cy="457200"/>
-          </a:xfrm>
-          <a:prstGeom prst="rect">
-            <a:avLst/>
-          </a:prstGeom>
-          <a:noFill/>
-        </p:spPr>
-        <p:txBody>
-          <a:bodyPr wrap="square" lIns="0" rIns="0" tIns="0" bIns="0">
-            <a:spAutoFit/>
-          </a:bodyPr>
-          <a:lstStyle/>
-          <a:p>
-            <a:pPr algn="l">
-              <a:spcAft>
-                <a:spcPts val="800"/>
-              </a:spcAft>
-              <a:defRPr sz="3000" b="1">
-                <a:solidFill>
-                  <a:srgbClr val="69E8DA"/>
-                </a:solidFill>
-                <a:latin typeface="Arial"/>
-              </a:defRPr>
-            </a:pPr>
-            <a:r>
-              <a:t>03</a:t>
-            </a:r>
-          </a:p>
-        </p:txBody>
-      </p:sp>
-      <p:sp>
-        <p:nvSpPr>
-          <p:cNvPr id="17" name="TextBox 16"/>
-          <p:cNvSpPr txBox="1"/>
-          <p:nvPr/>
-        </p:nvSpPr>
-        <p:spPr>
-          <a:xfrm>
-            <a:off x="1618488" y="4096512"/>
-            <a:ext cx="4114800" cy="329184"/>
-          </a:xfrm>
-          <a:prstGeom prst="rect">
-            <a:avLst/>
-          </a:prstGeom>
-          <a:noFill/>
-        </p:spPr>
-        <p:txBody>
-          <a:bodyPr wrap="square" lIns="0" rIns="0" tIns="0" bIns="0">
-            <a:spAutoFit/>
-          </a:bodyPr>
-          <a:lstStyle/>
-          <a:p>
-            <a:pPr algn="l">
-              <a:spcAft>
-                <a:spcPts val="800"/>
-              </a:spcAft>
-              <a:defRPr sz="1700" b="1">
-                <a:solidFill>
-                  <a:srgbClr val="F3F7FF"/>
-                </a:solidFill>
-                <a:latin typeface="Arial"/>
-              </a:defRPr>
-            </a:pPr>
-            <a:r>
-              <a:t>REVIEW THE EVIDENCE</a:t>
-            </a:r>
-          </a:p>
-        </p:txBody>
-      </p:sp>
-      <p:sp>
-        <p:nvSpPr>
-          <p:cNvPr id="18" name="TextBox 17"/>
-          <p:cNvSpPr txBox="1"/>
-          <p:nvPr/>
-        </p:nvSpPr>
-        <p:spPr>
-          <a:xfrm>
-            <a:off x="1618488" y="4599432"/>
-            <a:ext cx="4114800" cy="594360"/>
-          </a:xfrm>
-          <a:prstGeom prst="rect">
-            <a:avLst/>
-          </a:prstGeom>
-          <a:noFill/>
-        </p:spPr>
-        <p:txBody>
-          <a:bodyPr wrap="square" lIns="0" rIns="0" tIns="0" bIns="0">
-            <a:spAutoFit/>
-          </a:bodyPr>
-          <a:lstStyle/>
-          <a:p>
-            <a:pPr algn="l">
-              <a:spcAft>
-                <a:spcPts val="800"/>
-              </a:spcAft>
-              <a:defRPr sz="1700" b="0">
-                <a:solidFill>
-                  <a:srgbClr val="ADBED5"/>
-                </a:solidFill>
-                <a:latin typeface="Arial"/>
-              </a:defRPr>
-            </a:pPr>
-            <a:r>
-              <a:t>Read the findings, explanations</a:t>
-            </a:r>
-          </a:p>
-          <a:p>
-            <a:pPr algn="l">
-              <a:spcAft>
-                <a:spcPts val="800"/>
-              </a:spcAft>
-              <a:defRPr sz="1700" b="0">
-                <a:solidFill>
-                  <a:srgbClr val="ADBED5"/>
-                </a:solidFill>
-                <a:latin typeface="Arial"/>
-              </a:defRPr>
-            </a:pPr>
-            <a:r>
-              <a:t>and suggested next steps.</a:t>
-            </a:r>
-          </a:p>
-        </p:txBody>
-      </p:sp>
-      <p:sp>
-        <p:nvSpPr>
-          <p:cNvPr id="19" name="Rounded Rectangle 18"/>
-          <p:cNvSpPr/>
-          <p:nvPr/>
-        </p:nvSpPr>
-        <p:spPr>
-          <a:xfrm>
-            <a:off x="6227064" y="3886200"/>
-            <a:ext cx="5458968" cy="1417320"/>
-          </a:xfrm>
-          <a:prstGeom prst="roundRect">
-            <a:avLst>
-              <a:gd name="adj" fmla="val 12000"/>
-            </a:avLst>
-          </a:prstGeom>
-          <a:solidFill>
-            <a:srgbClr val="13243B"/>
-          </a:solidFill>
-          <a:ln>
-            <a:solidFill>
-              <a:srgbClr val="2A405A"/>
-            </a:solidFill>
-          </a:ln>
-        </p:spPr>
-        <p:style>
-          <a:lnRef idx="1">
-            <a:schemeClr val="accent1"/>
-          </a:lnRef>
-          <a:fillRef idx="3">
-            <a:schemeClr val="accent1"/>
-          </a:fillRef>
-          <a:effectRef idx="2">
-            <a:schemeClr val="accent1"/>
-          </a:effectRef>
-          <a:fontRef idx="minor">
-            <a:schemeClr val="lt1"/>
-          </a:fontRef>
-        </p:style>
-        <p:txBody>
-          <a:bodyPr rtlCol="0" anchor="ctr"/>
-          <a:lstStyle/>
-          <a:p>
-            <a:pPr algn="ctr"/>
-          </a:p>
-        </p:txBody>
-      </p:sp>
-      <p:sp>
-        <p:nvSpPr>
-          <p:cNvPr id="20" name="TextBox 19"/>
-          <p:cNvSpPr txBox="1"/>
-          <p:nvPr/>
-        </p:nvSpPr>
-        <p:spPr>
-          <a:xfrm>
-            <a:off x="6428231" y="4087368"/>
-            <a:ext cx="640080" cy="457200"/>
-          </a:xfrm>
-          <a:prstGeom prst="rect">
-            <a:avLst/>
-          </a:prstGeom>
-          <a:noFill/>
-        </p:spPr>
-        <p:txBody>
-          <a:bodyPr wrap="square" lIns="0" rIns="0" tIns="0" bIns="0">
-            <a:spAutoFit/>
-          </a:bodyPr>
-          <a:lstStyle/>
-          <a:p>
-            <a:pPr algn="l">
-              <a:spcAft>
-                <a:spcPts val="800"/>
-              </a:spcAft>
-              <a:defRPr sz="3000" b="1">
-                <a:solidFill>
-                  <a:srgbClr val="BEAEFF"/>
-                </a:solidFill>
-                <a:latin typeface="Arial"/>
-              </a:defRPr>
-            </a:pPr>
-            <a:r>
-              <a:t>04</a:t>
-            </a:r>
-          </a:p>
-        </p:txBody>
-      </p:sp>
-      <p:sp>
-        <p:nvSpPr>
-          <p:cNvPr id="21" name="TextBox 20"/>
-          <p:cNvSpPr txBox="1"/>
-          <p:nvPr/>
-        </p:nvSpPr>
-        <p:spPr>
-          <a:xfrm>
-            <a:off x="7232904" y="4096512"/>
-            <a:ext cx="4114800" cy="329184"/>
-          </a:xfrm>
-          <a:prstGeom prst="rect">
-            <a:avLst/>
-          </a:prstGeom>
-          <a:noFill/>
-        </p:spPr>
-        <p:txBody>
-          <a:bodyPr wrap="square" lIns="0" rIns="0" tIns="0" bIns="0">
-            <a:spAutoFit/>
-          </a:bodyPr>
-          <a:lstStyle/>
-          <a:p>
-            <a:pPr algn="l">
-              <a:spcAft>
-                <a:spcPts val="800"/>
-              </a:spcAft>
-              <a:defRPr sz="1700" b="1">
-                <a:solidFill>
-                  <a:srgbClr val="F3F7FF"/>
-                </a:solidFill>
-                <a:latin typeface="Arial"/>
-              </a:defRPr>
-            </a:pPr>
-            <a:r>
-              <a:t>VERIFY BEFORE ACTING</a:t>
-            </a:r>
-          </a:p>
-        </p:txBody>
-      </p:sp>
-      <p:sp>
-        <p:nvSpPr>
-          <p:cNvPr id="22" name="TextBox 21"/>
-          <p:cNvSpPr txBox="1"/>
-          <p:nvPr/>
-        </p:nvSpPr>
-        <p:spPr>
-          <a:xfrm>
-            <a:off x="7232904" y="4599432"/>
-            <a:ext cx="4114800" cy="594360"/>
-          </a:xfrm>
-          <a:prstGeom prst="rect">
-            <a:avLst/>
-          </a:prstGeom>
-          <a:noFill/>
-        </p:spPr>
-        <p:txBody>
-          <a:bodyPr wrap="square" lIns="0" rIns="0" tIns="0" bIns="0">
-            <a:spAutoFit/>
-          </a:bodyPr>
-          <a:lstStyle/>
-          <a:p>
-            <a:pPr algn="l">
-              <a:spcAft>
-                <a:spcPts val="800"/>
-              </a:spcAft>
-              <a:defRPr sz="1700" b="0">
-                <a:solidFill>
-                  <a:srgbClr val="ADBED5"/>
-                </a:solidFill>
-                <a:latin typeface="Arial"/>
-              </a:defRPr>
-            </a:pPr>
-            <a:r>
-              <a:t>Check the sender independently</a:t>
-            </a:r>
-          </a:p>
-          <a:p>
-            <a:pPr algn="l">
-              <a:spcAft>
-                <a:spcPts val="800"/>
-              </a:spcAft>
-              <a:defRPr sz="1700" b="0">
-                <a:solidFill>
-                  <a:srgbClr val="ADBED5"/>
-                </a:solidFill>
-                <a:latin typeface="Arial"/>
-              </a:defRPr>
-            </a:pPr>
-            <a:r>
-              <a:t>before paying or sharing details.</a:t>
-            </a:r>
-          </a:p>
-        </p:txBody>
-      </p:sp>
-      <p:sp>
-        <p:nvSpPr>
-          <p:cNvPr id="23" name="TextBox 22"/>
-          <p:cNvSpPr txBox="1"/>
-          <p:nvPr/>
-        </p:nvSpPr>
-        <p:spPr>
-          <a:xfrm>
-            <a:off x="658368" y="5925312"/>
-            <a:ext cx="10881360" cy="320040"/>
-          </a:xfrm>
-          <a:prstGeom prst="rect">
-            <a:avLst/>
-          </a:prstGeom>
-          <a:noFill/>
-        </p:spPr>
-        <p:txBody>
-          <a:bodyPr wrap="square" lIns="0" rIns="0" tIns="0" bIns="0">
-            <a:spAutoFit/>
-          </a:bodyPr>
-          <a:lstStyle/>
-          <a:p>
-            <a:pPr algn="l">
-              <a:spcAft>
-                <a:spcPts val="800"/>
-              </a:spcAft>
-              <a:defRPr sz="1700" b="0">
-                <a:solidFill>
-                  <a:srgbClr val="FFD69D"/>
-                </a:solidFill>
-                <a:latin typeface="Arial"/>
-              </a:defRPr>
-            </a:pPr>
-            <a:r>
-              <a:t>Current build: audio and pasted text are separate inputs.</a:t>
-            </a:r>
-          </a:p>
-        </p:txBody>
-      </p:sp>
     </p:spTree>
   </p:cSld>
   <p:clrMapOvr>
@@ -5648,7 +4592,7 @@
               </a:defRPr>
             </a:pPr>
             <a:r>
-              <a:t>03 / 06</a:t>
+              <a:t>02 / 05</a:t>
             </a:r>
           </a:p>
         </p:txBody>
@@ -6495,7 +5439,7 @@
               </a:defRPr>
             </a:pPr>
             <a:r>
-              <a:t>04 / 06</a:t>
+              <a:t>03 / 05</a:t>
             </a:r>
           </a:p>
         </p:txBody>
@@ -7248,7 +6192,7 @@
               </a:defRPr>
             </a:pPr>
             <a:r>
-              <a:t>05 / 06</a:t>
+              <a:t>04 / 05</a:t>
             </a:r>
           </a:p>
         </p:txBody>
@@ -8081,7 +7025,7 @@
               </a:defRPr>
             </a:pPr>
             <a:r>
-              <a:t>06 / 06</a:t>
+              <a:t>05 / 05</a:t>
             </a:r>
           </a:p>
         </p:txBody>

</xml_diff>